<commit_message>
change from production vps to localhost deploy
</commit_message>
<xml_diff>
--- a/diagrams-xml/MyBahaya_FYP1.pptx
+++ b/diagrams-xml/MyBahaya_FYP1.pptx
@@ -4,6 +4,9 @@
   <p:sldMasterIdLst>
     <p:sldMasterId id="2147483648" r:id="rId1"/>
   </p:sldMasterIdLst>
+  <p:notesMasterIdLst>
+    <p:notesMasterId r:id="rId13"/>
+  </p:notesMasterIdLst>
   <p:sldIdLst>
     <p:sldId id="256" r:id="rId2"/>
     <p:sldId id="257" r:id="rId3"/>
@@ -17,10 +20,7 @@
     <p:sldId id="265" r:id="rId11"/>
     <p:sldId id="266" r:id="rId12"/>
   </p:sldIdLst>
-  <p:notesMasterIdLst>
-    <p:notesMasterId r:id="rId13"/>
-  </p:notesMasterIdLst>
-  <p:sldSz cx="9144000" cy="5143500"/>
+  <p:sldSz cx="9144000" cy="5143500" type="screen16x9"/>
   <p:notesSz cx="5143500" cy="9144000"/>
   <p:defaultTextStyle>
     <a:lvl1pPr marL="0" algn="l" defTabSz="914400" rtl="0" eaLnBrk="1" latinLnBrk="0" hangingPunct="1">
@@ -114,6 +114,11 @@
       </a:defRPr>
     </a:lvl9pPr>
   </p:defaultTextStyle>
+  <p:extLst>
+    <p:ext uri="{EFAFB233-063F-42B5-8137-9DF3F51BA10A}">
+      <p15:sldGuideLst xmlns:p15="http://schemas.microsoft.com/office/powerpoint/2012/main"/>
+    </p:ext>
+  </p:extLst>
 </p:presentation>
 </file>
 
@@ -139,234 +144,10 @@
           <a:chExt cx="0" cy="0"/>
         </a:xfrm>
       </p:grpSpPr>
-      <p:sp>
-        <p:nvSpPr>
-          <p:cNvPr id="2" name="Header Placeholder 1"/>
-          <p:cNvSpPr>
-            <a:spLocks noGrp="1"/>
-          </p:cNvSpPr>
-          <p:nvPr>
-            <p:ph type="hdr" sz="quarter"/>
-          </p:nvPr>
-        </p:nvSpPr>
-        <p:spPr>
-          <a:xfrm>
-            <a:off x="0" y="0"/>
-            <a:ext cx="2971800" cy="458788"/>
-          </a:xfrm>
-          <a:prstGeom prst="rect">
-            <a:avLst/>
-          </a:prstGeom>
-        </p:spPr>
-        <p:txBody>
-          <a:bodyPr vert="horz" lIns="91440" tIns="45720" rIns="91440" bIns="45720" rtlCol="0"/>
-          <a:lstStyle>
-            <a:lvl1pPr algn="l">
-              <a:defRPr sz="1200"/>
-            </a:lvl1pPr>
-          </a:lstStyle>
-          <a:p>
-            <a:endParaRPr lang="en-US"/>
-          </a:p>
-        </p:txBody>
-      </p:sp>
-      <p:sp>
-        <p:nvSpPr>
-          <p:cNvPr id="3" name="Date Placeholder 2"/>
-          <p:cNvSpPr>
-            <a:spLocks noGrp="1"/>
-          </p:cNvSpPr>
-          <p:nvPr>
-            <p:ph type="dt" idx="1"/>
-          </p:nvPr>
-        </p:nvSpPr>
-        <p:spPr>
-          <a:xfrm>
-            <a:off x="3884613" y="0"/>
-            <a:ext cx="2971800" cy="458788"/>
-          </a:xfrm>
-          <a:prstGeom prst="rect">
-            <a:avLst/>
-          </a:prstGeom>
-        </p:spPr>
-        <p:txBody>
-          <a:bodyPr vert="horz" lIns="91440" tIns="45720" rIns="91440" bIns="45720" rtlCol="0"/>
-          <a:lstStyle>
-            <a:lvl1pPr algn="r">
-              <a:defRPr sz="1200"/>
-            </a:lvl1pPr>
-          </a:lstStyle>
-          <a:p>
-            <a:fld id="{5282F153-3F37-0F45-9E97-73ACFA13230C}" type="datetimeFigureOut">
-              <a:rPr lang="en-US"/>
-              <a:t>7/23/19</a:t>
-            </a:fld>
-            <a:endParaRPr lang="en-US"/>
-          </a:p>
-        </p:txBody>
-      </p:sp>
-      <p:sp>
-        <p:nvSpPr>
-          <p:cNvPr id="4" name="Slide Image Placeholder 3"/>
-          <p:cNvSpPr>
-            <a:spLocks noGrp="1" noRot="1" noChangeAspect="1"/>
-          </p:cNvSpPr>
-          <p:nvPr>
-            <p:ph type="sldImg" idx="2"/>
-          </p:nvPr>
-        </p:nvSpPr>
-        <p:spPr>
-          <a:xfrm>
-            <a:off x="685800" y="1143000"/>
-            <a:ext cx="5486400" cy="3086100"/>
-          </a:xfrm>
-          <a:prstGeom prst="rect">
-            <a:avLst/>
-          </a:prstGeom>
-          <a:noFill/>
-          <a:ln w="12700">
-            <a:solidFill>
-              <a:prstClr val="black"/>
-            </a:solidFill>
-          </a:ln>
-        </p:spPr>
-        <p:txBody>
-          <a:bodyPr vert="horz" lIns="91440" tIns="45720" rIns="91440" bIns="45720" rtlCol="0" anchor="ctr"/>
-          <a:lstStyle/>
-          <a:p>
-            <a:endParaRPr lang="en-US"/>
-          </a:p>
-        </p:txBody>
-      </p:sp>
-      <p:sp>
-        <p:nvSpPr>
-          <p:cNvPr id="5" name="Notes Placeholder 4"/>
-          <p:cNvSpPr>
-            <a:spLocks noGrp="1"/>
-          </p:cNvSpPr>
-          <p:nvPr>
-            <p:ph type="body" sz="quarter" idx="3"/>
-          </p:nvPr>
-        </p:nvSpPr>
-        <p:spPr>
-          <a:xfrm>
-            <a:off x="685800" y="4400550"/>
-            <a:ext cx="5486400" cy="3600450"/>
-          </a:xfrm>
-          <a:prstGeom prst="rect">
-            <a:avLst/>
-          </a:prstGeom>
-        </p:spPr>
-        <p:txBody>
-          <a:bodyPr vert="horz" lIns="91440" tIns="45720" rIns="91440" bIns="45720" rtlCol="0"/>
-          <a:lstStyle/>
-          <a:p>
-            <a:pPr lvl="0"/>
-            <a:r>
-              <a:rPr lang="en-US"/>
-              <a:t>Click to edit Master text styles</a:t>
-            </a:r>
-          </a:p>
-          <a:p>
-            <a:pPr lvl="1"/>
-            <a:r>
-              <a:rPr lang="en-US"/>
-              <a:t>Second level</a:t>
-            </a:r>
-          </a:p>
-          <a:p>
-            <a:pPr lvl="2"/>
-            <a:r>
-              <a:rPr lang="en-US"/>
-              <a:t>Third level</a:t>
-            </a:r>
-          </a:p>
-          <a:p>
-            <a:pPr lvl="3"/>
-            <a:r>
-              <a:rPr lang="en-US"/>
-              <a:t>Fourth level</a:t>
-            </a:r>
-          </a:p>
-          <a:p>
-            <a:pPr lvl="4"/>
-            <a:r>
-              <a:rPr lang="en-US"/>
-              <a:t>Fifth level</a:t>
-            </a:r>
-          </a:p>
-        </p:txBody>
-      </p:sp>
-      <p:sp>
-        <p:nvSpPr>
-          <p:cNvPr id="6" name="Footer Placeholder 5"/>
-          <p:cNvSpPr>
-            <a:spLocks noGrp="1"/>
-          </p:cNvSpPr>
-          <p:nvPr>
-            <p:ph type="ftr" sz="quarter" idx="4"/>
-          </p:nvPr>
-        </p:nvSpPr>
-        <p:spPr>
-          <a:xfrm>
-            <a:off x="0" y="8685213"/>
-            <a:ext cx="2971800" cy="458787"/>
-          </a:xfrm>
-          <a:prstGeom prst="rect">
-            <a:avLst/>
-          </a:prstGeom>
-        </p:spPr>
-        <p:txBody>
-          <a:bodyPr vert="horz" lIns="91440" tIns="45720" rIns="91440" bIns="45720" rtlCol="0" anchor="b"/>
-          <a:lstStyle>
-            <a:lvl1pPr algn="l">
-              <a:defRPr sz="1200"/>
-            </a:lvl1pPr>
-          </a:lstStyle>
-          <a:p>
-            <a:endParaRPr lang="en-US"/>
-          </a:p>
-        </p:txBody>
-      </p:sp>
-      <p:sp>
-        <p:nvSpPr>
-          <p:cNvPr id="7" name="Slide Number Placeholder 6"/>
-          <p:cNvSpPr>
-            <a:spLocks noGrp="1"/>
-          </p:cNvSpPr>
-          <p:nvPr>
-            <p:ph type="sldNum" sz="quarter" idx="5"/>
-          </p:nvPr>
-        </p:nvSpPr>
-        <p:spPr>
-          <a:xfrm>
-            <a:off x="3884613" y="8685213"/>
-            <a:ext cx="2971800" cy="458787"/>
-          </a:xfrm>
-          <a:prstGeom prst="rect">
-            <a:avLst/>
-          </a:prstGeom>
-        </p:spPr>
-        <p:txBody>
-          <a:bodyPr vert="horz" lIns="91440" tIns="45720" rIns="91440" bIns="45720" rtlCol="0" anchor="b"/>
-          <a:lstStyle>
-            <a:lvl1pPr algn="r">
-              <a:defRPr sz="1200"/>
-            </a:lvl1pPr>
-          </a:lstStyle>
-          <a:p>
-            <a:fld id="{CE5E9CC1-C706-0F49-92D6-E571CC5EEA8F}" type="slidenum">
-              <a:rPr lang="en-US"/>
-              <a:t>‹#›</a:t>
-            </a:fld>
-            <a:endParaRPr lang="en-US"/>
-          </a:p>
-        </p:txBody>
-      </p:sp>
     </p:spTree>
     <p:extLst>
       <p:ext uri="{BB962C8B-B14F-4D97-AF65-F5344CB8AC3E}">
-        <p14:creationId xmlns:p14="http://schemas.microsoft.com/office/powerpoint/2010/main" val="1024086991"/>
+        <p14:creationId xmlns:p14="http://schemas.microsoft.com/office/powerpoint/2010/main" val="4277568683"/>
       </p:ext>
     </p:extLst>
   </p:cSld>
@@ -514,7 +295,6 @@
               <a:rPr lang="en-US" dirty="0"/>
               <a:t>Assalamualaikum. Good morning, evaluators. My name is Ahmad Shukri. Today I present MyBahaya — an AI-powered emergency reporting and real-time community alert platform for Malaysia.</a:t>
             </a:r>
-            <a:endParaRPr lang="en-US" dirty="0"/>
           </a:p>
         </p:txBody>
       </p:sp>
@@ -602,7 +382,6 @@
               <a:rPr lang="en-US" dirty="0"/>
               <a:t>Three-tier architecture: Client (Flutter + Web browser), Application (Spring Boot REST API on VPS), Data (Firebase Firestore, MinIO, Gemini AI, FCM).</a:t>
             </a:r>
-            <a:endParaRPr lang="en-US" dirty="0"/>
           </a:p>
         </p:txBody>
       </p:sp>
@@ -690,7 +469,6 @@
               <a:rPr lang="en-US" dirty="0"/>
               <a:t>MyBahaya addresses all four identified problems and is fully deployed. Ready for the tool demo. Open for questions.</a:t>
             </a:r>
-            <a:endParaRPr lang="en-US" dirty="0"/>
           </a:p>
         </p:txBody>
       </p:sp>
@@ -778,7 +556,6 @@
               <a:rPr lang="en-US" dirty="0"/>
               <a:t>MyBahaya has three user types: citizens, organizations, admins. Flow: submit → AI → route → notify → track.</a:t>
             </a:r>
-            <a:endParaRPr lang="en-US" dirty="0"/>
           </a:p>
         </p:txBody>
       </p:sp>
@@ -866,7 +643,6 @@
               <a:rPr lang="en-US" dirty="0"/>
               <a:t>Four problems: no reporting app, slow routing, no community awareness, fake reports. These gaps justify MyBahaya.</a:t>
             </a:r>
-            <a:endParaRPr lang="en-US" dirty="0"/>
           </a:p>
         </p:txBody>
       </p:sp>
@@ -954,7 +730,6 @@
               <a:rPr lang="en-US" dirty="0"/>
               <a:t>All statistics from real sources. 99.5% phone ownership confirms mobile reach. 84.7% ambulance delay + response times exceeding WHO benchmarks prove the problem. 169,000 fake calls in 2025 and only 2-3% real calls justify AI fake detection in MyBahaya.</a:t>
             </a:r>
-            <a:endParaRPr lang="en-US" dirty="0"/>
           </a:p>
         </p:txBody>
       </p:sp>
@@ -1042,7 +817,6 @@
               <a:rPr lang="en-US" dirty="0"/>
               <a:t>Only MyBahaya provides all six features. Competitors lack AI analysis, auto routing, and fake detection.</a:t>
             </a:r>
-            <a:endParaRPr lang="en-US" dirty="0"/>
           </a:p>
         </p:txBody>
       </p:sp>
@@ -1130,7 +904,6 @@
               <a:rPr lang="en-US" dirty="0"/>
               <a:t>Three objectives: build mobile reporting app, implement Gemini AI analysis, design geolocation routing system.</a:t>
             </a:r>
-            <a:endParaRPr lang="en-US" dirty="0"/>
           </a:p>
         </p:txBody>
       </p:sp>
@@ -1218,7 +991,6 @@
               <a:rPr lang="en-US" dirty="0"/>
               <a:t>Scope: Android for citizens, organizations, admins. Peninsular Malaysia. Five categories. iOS and government APIs excluded in FYP1.</a:t>
             </a:r>
-            <a:endParaRPr lang="en-US" dirty="0"/>
           </a:p>
         </p:txBody>
       </p:sp>
@@ -1306,7 +1078,6 @@
               <a:rPr lang="en-US" dirty="0"/>
               <a:t>Five Firestore collections. Reports link to Users via userId, to Organisations via assignedOrgId, and mirror sanitised data to Public Incidents. Admins manage the platform.</a:t>
             </a:r>
-            <a:endParaRPr lang="en-US" dirty="0"/>
           </a:p>
         </p:txBody>
       </p:sp>
@@ -1394,7 +1165,6 @@
               <a:rPr lang="en-US" dirty="0"/>
               <a:t>Agile SDLC chosen for its iterative nature. Six phases: Planning through Deployment. Each sprint reviewed with supervisor.</a:t>
             </a:r>
-            <a:endParaRPr lang="en-US" dirty="0"/>
           </a:p>
         </p:txBody>
       </p:sp>
@@ -1467,6 +1237,11 @@
 <file path=ppt/slideMasters/slideMaster1.xml><?xml version="1.0" encoding="utf-8"?>
 <p:sldMaster xmlns:a="http://schemas.openxmlformats.org/drawingml/2006/main" xmlns:r="http://schemas.openxmlformats.org/officeDocument/2006/relationships" xmlns:p="http://schemas.openxmlformats.org/presentationml/2006/main">
   <p:cSld>
+    <p:bg>
+      <p:bgRef idx="1001">
+        <a:schemeClr val="bg1"/>
+      </p:bgRef>
+    </p:bg>
     <p:spTree>
       <p:nvGrpSpPr>
         <p:cNvPr id="1" name=""/>
@@ -1749,6 +1524,7 @@
         <a:solidFill>
           <a:srgbClr val="341515"/>
         </a:solidFill>
+        <a:effectLst/>
       </p:bgPr>
     </p:bg>
     <p:spTree>
@@ -1791,6 +1567,13 @@
             <a:prstDash val="solid"/>
           </a:ln>
         </p:spPr>
+        <p:txBody>
+          <a:bodyPr/>
+          <a:lstStyle/>
+          <a:p>
+            <a:endParaRPr lang="en-US"/>
+          </a:p>
+        </p:txBody>
       </p:sp>
       <p:sp>
         <p:nvSpPr>
@@ -1818,6 +1601,13 @@
             <a:prstDash val="solid"/>
           </a:ln>
         </p:spPr>
+        <p:txBody>
+          <a:bodyPr/>
+          <a:lstStyle/>
+          <a:p>
+            <a:endParaRPr lang="en-US"/>
+          </a:p>
+        </p:txBody>
       </p:sp>
       <p:sp>
         <p:nvSpPr>
@@ -1840,7 +1630,7 @@
           <a:bodyPr wrap="square" lIns="0" tIns="0" rIns="0" bIns="0" rtlCol="0" anchor="ctr"/>
           <a:lstStyle/>
           <a:p>
-            <a:pPr algn="l" indent="0" marL="0">
+            <a:pPr marL="0" indent="0" algn="l">
               <a:buNone/>
             </a:pPr>
             <a:r>
@@ -1879,7 +1669,7 @@
           <a:bodyPr wrap="square" lIns="0" tIns="0" rIns="0" bIns="0" rtlCol="0" anchor="ctr"/>
           <a:lstStyle/>
           <a:p>
-            <a:pPr algn="l" indent="0" marL="0">
+            <a:pPr marL="0" indent="0" algn="l">
               <a:buNone/>
             </a:pPr>
             <a:r>
@@ -1919,6 +1709,13 @@
             <a:prstDash val="solid"/>
           </a:ln>
         </p:spPr>
+        <p:txBody>
+          <a:bodyPr/>
+          <a:lstStyle/>
+          <a:p>
+            <a:endParaRPr lang="en-US"/>
+          </a:p>
+        </p:txBody>
       </p:sp>
       <p:sp>
         <p:nvSpPr>
@@ -1941,7 +1738,7 @@
           <a:bodyPr wrap="square" lIns="0" tIns="0" rIns="0" bIns="0" rtlCol="0" anchor="ctr"/>
           <a:lstStyle/>
           <a:p>
-            <a:pPr algn="l" indent="0" marL="0">
+            <a:pPr marL="0" indent="0" algn="l">
               <a:buNone/>
             </a:pPr>
             <a:r>
@@ -1975,6 +1772,7 @@
         <a:solidFill>
           <a:srgbClr val="FFFFFF"/>
         </a:solidFill>
+        <a:effectLst/>
       </p:bgPr>
     </p:bg>
     <p:spTree>
@@ -2012,7 +1810,7 @@
           <a:bodyPr wrap="square" lIns="0" tIns="0" rIns="0" bIns="0" rtlCol="0" anchor="ctr"/>
           <a:lstStyle/>
           <a:p>
-            <a:pPr algn="l" indent="0" marL="0">
+            <a:pPr marL="0" indent="0" algn="l">
               <a:buNone/>
             </a:pPr>
             <a:r>
@@ -2056,6 +1854,13 @@
             <a:prstDash val="dash"/>
           </a:ln>
         </p:spPr>
+        <p:txBody>
+          <a:bodyPr/>
+          <a:lstStyle/>
+          <a:p>
+            <a:endParaRPr lang="en-US"/>
+          </a:p>
+        </p:txBody>
       </p:sp>
       <p:sp>
         <p:nvSpPr>
@@ -2078,7 +1883,7 @@
           <a:bodyPr wrap="square" lIns="0" tIns="0" rIns="0" bIns="0" rtlCol="0" anchor="ctr"/>
           <a:lstStyle/>
           <a:p>
-            <a:pPr algn="ctr" indent="0" marL="0">
+            <a:pPr marL="0" indent="0" algn="ctr">
               <a:buNone/>
             </a:pPr>
             <a:r>
@@ -2117,7 +1922,7 @@
           <a:bodyPr wrap="square" lIns="0" tIns="0" rIns="0" bIns="0" rtlCol="0" anchor="ctr"/>
           <a:lstStyle/>
           <a:p>
-            <a:pPr algn="ctr" indent="0" marL="0">
+            <a:pPr marL="0" indent="0" algn="ctr">
               <a:buNone/>
             </a:pPr>
             <a:r>
@@ -2161,6 +1966,13 @@
             <a:prstDash val="solid"/>
           </a:ln>
         </p:spPr>
+        <p:txBody>
+          <a:bodyPr/>
+          <a:lstStyle/>
+          <a:p>
+            <a:endParaRPr lang="en-US"/>
+          </a:p>
+        </p:txBody>
       </p:sp>
       <p:sp>
         <p:nvSpPr>
@@ -2183,7 +1995,7 @@
           <a:bodyPr wrap="square" lIns="0" tIns="0" rIns="0" bIns="0" rtlCol="0" anchor="ctr"/>
           <a:lstStyle/>
           <a:p>
-            <a:pPr algn="ctr" indent="0" marL="0">
+            <a:pPr marL="0" indent="0" algn="ctr">
               <a:buNone/>
             </a:pPr>
             <a:r>
@@ -2227,6 +2039,13 @@
             <a:prstDash val="solid"/>
           </a:ln>
         </p:spPr>
+        <p:txBody>
+          <a:bodyPr/>
+          <a:lstStyle/>
+          <a:p>
+            <a:endParaRPr lang="en-US"/>
+          </a:p>
+        </p:txBody>
       </p:sp>
       <p:sp>
         <p:nvSpPr>
@@ -2249,7 +2068,7 @@
           <a:bodyPr wrap="square" lIns="0" tIns="0" rIns="0" bIns="0" rtlCol="0" anchor="ctr"/>
           <a:lstStyle/>
           <a:p>
-            <a:pPr algn="ctr" indent="0" marL="0">
+            <a:pPr marL="0" indent="0" algn="ctr">
               <a:buNone/>
             </a:pPr>
             <a:r>
@@ -2293,6 +2112,13 @@
             <a:prstDash val="solid"/>
           </a:ln>
         </p:spPr>
+        <p:txBody>
+          <a:bodyPr/>
+          <a:lstStyle/>
+          <a:p>
+            <a:endParaRPr lang="en-US"/>
+          </a:p>
+        </p:txBody>
       </p:sp>
       <p:sp>
         <p:nvSpPr>
@@ -2315,7 +2141,7 @@
           <a:bodyPr wrap="square" lIns="0" tIns="0" rIns="0" bIns="0" rtlCol="0" anchor="ctr"/>
           <a:lstStyle/>
           <a:p>
-            <a:pPr algn="ctr" indent="0" marL="0">
+            <a:pPr marL="0" indent="0" algn="ctr">
               <a:buNone/>
             </a:pPr>
             <a:r>
@@ -2359,6 +2185,13 @@
             <a:prstDash val="solid"/>
           </a:ln>
         </p:spPr>
+        <p:txBody>
+          <a:bodyPr/>
+          <a:lstStyle/>
+          <a:p>
+            <a:endParaRPr lang="en-US"/>
+          </a:p>
+        </p:txBody>
       </p:sp>
       <p:sp>
         <p:nvSpPr>
@@ -2381,7 +2214,7 @@
           <a:bodyPr wrap="square" lIns="0" tIns="0" rIns="0" bIns="0" rtlCol="0" anchor="ctr"/>
           <a:lstStyle/>
           <a:p>
-            <a:pPr algn="ctr" indent="0" marL="0">
+            <a:pPr marL="0" indent="0" algn="ctr">
               <a:buNone/>
             </a:pPr>
             <a:r>
@@ -2425,6 +2258,13 @@
             <a:prstDash val="solid"/>
           </a:ln>
         </p:spPr>
+        <p:txBody>
+          <a:bodyPr/>
+          <a:lstStyle/>
+          <a:p>
+            <a:endParaRPr lang="en-US"/>
+          </a:p>
+        </p:txBody>
       </p:sp>
       <p:sp>
         <p:nvSpPr>
@@ -2447,7 +2287,7 @@
           <a:bodyPr wrap="square" lIns="0" tIns="0" rIns="0" bIns="0" rtlCol="0" anchor="ctr"/>
           <a:lstStyle/>
           <a:p>
-            <a:pPr algn="ctr" indent="0" marL="0">
+            <a:pPr marL="0" indent="0" algn="ctr">
               <a:buNone/>
             </a:pPr>
             <a:r>
@@ -2491,6 +2331,13 @@
             <a:prstDash val="solid"/>
           </a:ln>
         </p:spPr>
+        <p:txBody>
+          <a:bodyPr/>
+          <a:lstStyle/>
+          <a:p>
+            <a:endParaRPr lang="en-US"/>
+          </a:p>
+        </p:txBody>
       </p:sp>
       <p:sp>
         <p:nvSpPr>
@@ -2513,7 +2360,7 @@
           <a:bodyPr wrap="square" lIns="0" tIns="0" rIns="0" bIns="0" rtlCol="0" anchor="ctr"/>
           <a:lstStyle/>
           <a:p>
-            <a:pPr algn="ctr" indent="0" marL="0">
+            <a:pPr marL="0" indent="0" algn="ctr">
               <a:buNone/>
             </a:pPr>
             <a:r>
@@ -2531,6 +2378,36 @@
           </a:p>
         </p:txBody>
       </p:sp>
+      <p:pic>
+        <p:nvPicPr>
+          <p:cNvPr id="19" name="Picture 18">
+            <a:extLst>
+              <a:ext uri="{FF2B5EF4-FFF2-40B4-BE49-F238E27FC236}">
+                <a16:creationId xmlns:a16="http://schemas.microsoft.com/office/drawing/2014/main" id="{CC29B228-3C51-44CD-7613-2F8BB820CE2F}"/>
+              </a:ext>
+            </a:extLst>
+          </p:cNvPr>
+          <p:cNvPicPr>
+            <a:picLocks noChangeAspect="1"/>
+          </p:cNvPicPr>
+          <p:nvPr/>
+        </p:nvPicPr>
+        <p:blipFill>
+          <a:blip r:embed="rId3"/>
+          <a:stretch>
+            <a:fillRect/>
+          </a:stretch>
+        </p:blipFill>
+        <p:spPr>
+          <a:xfrm>
+            <a:off x="1980500" y="914400"/>
+            <a:ext cx="5170174" cy="3657600"/>
+          </a:xfrm>
+          <a:prstGeom prst="rect">
+            <a:avLst/>
+          </a:prstGeom>
+        </p:spPr>
+      </p:pic>
     </p:spTree>
   </p:cSld>
   <p:clrMapOvr>
@@ -2547,6 +2424,7 @@
         <a:solidFill>
           <a:srgbClr val="341515"/>
         </a:solidFill>
+        <a:effectLst/>
       </p:bgPr>
     </p:bg>
     <p:spTree>
@@ -2589,6 +2467,13 @@
             <a:prstDash val="solid"/>
           </a:ln>
         </p:spPr>
+        <p:txBody>
+          <a:bodyPr/>
+          <a:lstStyle/>
+          <a:p>
+            <a:endParaRPr lang="en-US"/>
+          </a:p>
+        </p:txBody>
       </p:sp>
       <p:sp>
         <p:nvSpPr>
@@ -2616,6 +2501,13 @@
             <a:prstDash val="solid"/>
           </a:ln>
         </p:spPr>
+        <p:txBody>
+          <a:bodyPr/>
+          <a:lstStyle/>
+          <a:p>
+            <a:endParaRPr lang="en-US"/>
+          </a:p>
+        </p:txBody>
       </p:sp>
       <p:sp>
         <p:nvSpPr>
@@ -2638,7 +2530,7 @@
           <a:bodyPr wrap="square" lIns="0" tIns="0" rIns="0" bIns="0" rtlCol="0" anchor="ctr"/>
           <a:lstStyle/>
           <a:p>
-            <a:pPr algn="l" indent="0" marL="0">
+            <a:pPr marL="0" indent="0" algn="l">
               <a:buNone/>
             </a:pPr>
             <a:r>
@@ -2680,6 +2572,13 @@
             <a:prstDash val="solid"/>
           </a:ln>
         </p:spPr>
+        <p:txBody>
+          <a:bodyPr/>
+          <a:lstStyle/>
+          <a:p>
+            <a:endParaRPr lang="en-US"/>
+          </a:p>
+        </p:txBody>
       </p:sp>
       <p:sp>
         <p:nvSpPr>
@@ -2702,7 +2601,7 @@
           <a:bodyPr wrap="square" lIns="0" tIns="0" rIns="0" bIns="0" rtlCol="0" anchor="ctr"/>
           <a:lstStyle/>
           <a:p>
-            <a:pPr algn="ctr" indent="0" marL="0">
+            <a:pPr marL="0" indent="0" algn="ctr">
               <a:buNone/>
             </a:pPr>
             <a:r>
@@ -2741,7 +2640,7 @@
           <a:bodyPr wrap="square" lIns="0" tIns="0" rIns="0" bIns="0" rtlCol="0" anchor="ctr"/>
           <a:lstStyle/>
           <a:p>
-            <a:pPr algn="l" indent="0" marL="0">
+            <a:pPr marL="0" indent="0" algn="l">
               <a:buNone/>
             </a:pPr>
             <a:r>
@@ -2783,6 +2682,13 @@
             <a:prstDash val="solid"/>
           </a:ln>
         </p:spPr>
+        <p:txBody>
+          <a:bodyPr/>
+          <a:lstStyle/>
+          <a:p>
+            <a:endParaRPr lang="en-US"/>
+          </a:p>
+        </p:txBody>
       </p:sp>
       <p:sp>
         <p:nvSpPr>
@@ -2805,7 +2711,7 @@
           <a:bodyPr wrap="square" lIns="0" tIns="0" rIns="0" bIns="0" rtlCol="0" anchor="ctr"/>
           <a:lstStyle/>
           <a:p>
-            <a:pPr algn="ctr" indent="0" marL="0">
+            <a:pPr marL="0" indent="0" algn="ctr">
               <a:buNone/>
             </a:pPr>
             <a:r>
@@ -2844,7 +2750,7 @@
           <a:bodyPr wrap="square" lIns="0" tIns="0" rIns="0" bIns="0" rtlCol="0" anchor="ctr"/>
           <a:lstStyle/>
           <a:p>
-            <a:pPr algn="l" indent="0" marL="0">
+            <a:pPr marL="0" indent="0" algn="l">
               <a:buNone/>
             </a:pPr>
             <a:r>
@@ -2886,6 +2792,13 @@
             <a:prstDash val="solid"/>
           </a:ln>
         </p:spPr>
+        <p:txBody>
+          <a:bodyPr/>
+          <a:lstStyle/>
+          <a:p>
+            <a:endParaRPr lang="en-US"/>
+          </a:p>
+        </p:txBody>
       </p:sp>
       <p:sp>
         <p:nvSpPr>
@@ -2908,7 +2821,7 @@
           <a:bodyPr wrap="square" lIns="0" tIns="0" rIns="0" bIns="0" rtlCol="0" anchor="ctr"/>
           <a:lstStyle/>
           <a:p>
-            <a:pPr algn="ctr" indent="0" marL="0">
+            <a:pPr marL="0" indent="0" algn="ctr">
               <a:buNone/>
             </a:pPr>
             <a:r>
@@ -2947,7 +2860,7 @@
           <a:bodyPr wrap="square" lIns="0" tIns="0" rIns="0" bIns="0" rtlCol="0" anchor="ctr"/>
           <a:lstStyle/>
           <a:p>
-            <a:pPr algn="l" indent="0" marL="0">
+            <a:pPr marL="0" indent="0" algn="l">
               <a:buNone/>
             </a:pPr>
             <a:r>
@@ -2989,6 +2902,13 @@
             <a:prstDash val="solid"/>
           </a:ln>
         </p:spPr>
+        <p:txBody>
+          <a:bodyPr/>
+          <a:lstStyle/>
+          <a:p>
+            <a:endParaRPr lang="en-US"/>
+          </a:p>
+        </p:txBody>
       </p:sp>
       <p:sp>
         <p:nvSpPr>
@@ -3011,7 +2931,7 @@
           <a:bodyPr wrap="square" lIns="0" tIns="0" rIns="0" bIns="0" rtlCol="0" anchor="ctr"/>
           <a:lstStyle/>
           <a:p>
-            <a:pPr algn="ctr" indent="0" marL="0">
+            <a:pPr marL="0" indent="0" algn="ctr">
               <a:buNone/>
             </a:pPr>
             <a:r>
@@ -3050,7 +2970,7 @@
           <a:bodyPr wrap="square" lIns="0" tIns="0" rIns="0" bIns="0" rtlCol="0" anchor="ctr"/>
           <a:lstStyle/>
           <a:p>
-            <a:pPr algn="l" indent="0" marL="0">
+            <a:pPr marL="0" indent="0" algn="l">
               <a:buNone/>
             </a:pPr>
             <a:r>
@@ -3089,7 +3009,7 @@
           <a:bodyPr wrap="square" lIns="0" tIns="0" rIns="0" bIns="0" rtlCol="0" anchor="ctr"/>
           <a:lstStyle/>
           <a:p>
-            <a:pPr algn="ctr" indent="0" marL="0">
+            <a:pPr marL="0" indent="0" algn="ctr">
               <a:buNone/>
             </a:pPr>
             <a:r>
@@ -3123,6 +3043,7 @@
         <a:solidFill>
           <a:srgbClr val="FFFFFF"/>
         </a:solidFill>
+        <a:effectLst/>
       </p:bgPr>
     </p:bg>
     <p:spTree>
@@ -3160,7 +3081,7 @@
           <a:bodyPr wrap="square" lIns="0" tIns="0" rIns="0" bIns="0" rtlCol="0" anchor="ctr"/>
           <a:lstStyle/>
           <a:p>
-            <a:pPr algn="l" indent="0" marL="0">
+            <a:pPr marL="0" indent="0" algn="l">
               <a:buNone/>
             </a:pPr>
             <a:r>
@@ -3204,13 +3125,20 @@
             <a:prstDash val="solid"/>
           </a:ln>
           <a:effectLst>
-            <a:outerShdw sx="100000" sy="100000" kx="0" ky="0" algn="bl" rotWithShape="0" blurRad="88900" dist="25400" dir="2700000">
+            <a:outerShdw blurRad="88900" dist="25400" dir="2700000" algn="bl" rotWithShape="0">
               <a:srgbClr val="000000">
                 <a:alpha val="10000"/>
               </a:srgbClr>
             </a:outerShdw>
           </a:effectLst>
         </p:spPr>
+        <p:txBody>
+          <a:bodyPr/>
+          <a:lstStyle/>
+          <a:p>
+            <a:endParaRPr lang="en-US"/>
+          </a:p>
+        </p:txBody>
       </p:sp>
       <p:sp>
         <p:nvSpPr>
@@ -3236,6 +3164,13 @@
             <a:prstDash val="solid"/>
           </a:ln>
         </p:spPr>
+        <p:txBody>
+          <a:bodyPr/>
+          <a:lstStyle/>
+          <a:p>
+            <a:endParaRPr lang="en-US"/>
+          </a:p>
+        </p:txBody>
       </p:sp>
       <p:sp>
         <p:nvSpPr>
@@ -3258,7 +3193,7 @@
           <a:bodyPr wrap="square" lIns="0" tIns="0" rIns="0" bIns="0" rtlCol="0" anchor="ctr"/>
           <a:lstStyle/>
           <a:p>
-            <a:pPr algn="ctr" indent="0" marL="0">
+            <a:pPr marL="0" indent="0" algn="ctr">
               <a:buNone/>
             </a:pPr>
             <a:r>
@@ -3297,7 +3232,7 @@
           <a:bodyPr wrap="square" lIns="0" tIns="0" rIns="0" bIns="0" rtlCol="0" anchor="t"/>
           <a:lstStyle/>
           <a:p>
-            <a:pPr algn="l" indent="0" marL="0">
+            <a:pPr marL="0" indent="0" algn="l">
               <a:buNone/>
             </a:pPr>
             <a:r>
@@ -3341,13 +3276,20 @@
             <a:prstDash val="solid"/>
           </a:ln>
           <a:effectLst>
-            <a:outerShdw sx="100000" sy="100000" kx="0" ky="0" algn="bl" rotWithShape="0" blurRad="88900" dist="25400" dir="2700000">
+            <a:outerShdw blurRad="88900" dist="25400" dir="2700000" algn="bl" rotWithShape="0">
               <a:srgbClr val="000000">
                 <a:alpha val="10000"/>
               </a:srgbClr>
             </a:outerShdw>
           </a:effectLst>
         </p:spPr>
+        <p:txBody>
+          <a:bodyPr/>
+          <a:lstStyle/>
+          <a:p>
+            <a:endParaRPr lang="en-US"/>
+          </a:p>
+        </p:txBody>
       </p:sp>
       <p:sp>
         <p:nvSpPr>
@@ -3373,6 +3315,13 @@
             <a:prstDash val="solid"/>
           </a:ln>
         </p:spPr>
+        <p:txBody>
+          <a:bodyPr/>
+          <a:lstStyle/>
+          <a:p>
+            <a:endParaRPr lang="en-US"/>
+          </a:p>
+        </p:txBody>
       </p:sp>
       <p:sp>
         <p:nvSpPr>
@@ -3395,7 +3344,7 @@
           <a:bodyPr wrap="square" lIns="0" tIns="0" rIns="0" bIns="0" rtlCol="0" anchor="ctr"/>
           <a:lstStyle/>
           <a:p>
-            <a:pPr algn="ctr" indent="0" marL="0">
+            <a:pPr marL="0" indent="0" algn="ctr">
               <a:buNone/>
             </a:pPr>
             <a:r>
@@ -3434,7 +3383,7 @@
           <a:bodyPr wrap="square" lIns="0" tIns="0" rIns="0" bIns="0" rtlCol="0" anchor="t"/>
           <a:lstStyle/>
           <a:p>
-            <a:pPr algn="l" indent="0" marL="0">
+            <a:pPr marL="0" indent="0" algn="l">
               <a:buNone/>
             </a:pPr>
             <a:r>
@@ -3478,13 +3427,20 @@
             <a:prstDash val="solid"/>
           </a:ln>
           <a:effectLst>
-            <a:outerShdw sx="100000" sy="100000" kx="0" ky="0" algn="bl" rotWithShape="0" blurRad="88900" dist="25400" dir="2700000">
+            <a:outerShdw blurRad="88900" dist="25400" dir="2700000" algn="bl" rotWithShape="0">
               <a:srgbClr val="000000">
                 <a:alpha val="10000"/>
               </a:srgbClr>
             </a:outerShdw>
           </a:effectLst>
         </p:spPr>
+        <p:txBody>
+          <a:bodyPr/>
+          <a:lstStyle/>
+          <a:p>
+            <a:endParaRPr lang="en-US"/>
+          </a:p>
+        </p:txBody>
       </p:sp>
       <p:sp>
         <p:nvSpPr>
@@ -3510,6 +3466,13 @@
             <a:prstDash val="solid"/>
           </a:ln>
         </p:spPr>
+        <p:txBody>
+          <a:bodyPr/>
+          <a:lstStyle/>
+          <a:p>
+            <a:endParaRPr lang="en-US"/>
+          </a:p>
+        </p:txBody>
       </p:sp>
       <p:sp>
         <p:nvSpPr>
@@ -3532,7 +3495,7 @@
           <a:bodyPr wrap="square" lIns="0" tIns="0" rIns="0" bIns="0" rtlCol="0" anchor="ctr"/>
           <a:lstStyle/>
           <a:p>
-            <a:pPr algn="ctr" indent="0" marL="0">
+            <a:pPr marL="0" indent="0" algn="ctr">
               <a:buNone/>
             </a:pPr>
             <a:r>
@@ -3571,7 +3534,7 @@
           <a:bodyPr wrap="square" lIns="0" tIns="0" rIns="0" bIns="0" rtlCol="0" anchor="t"/>
           <a:lstStyle/>
           <a:p>
-            <a:pPr algn="l" indent="0" marL="0">
+            <a:pPr marL="0" indent="0" algn="l">
               <a:buNone/>
             </a:pPr>
             <a:r>
@@ -3605,6 +3568,7 @@
         <a:solidFill>
           <a:srgbClr val="FFFFFF"/>
         </a:solidFill>
+        <a:effectLst/>
       </p:bgPr>
     </p:bg>
     <p:spTree>
@@ -3642,7 +3606,7 @@
           <a:bodyPr wrap="square" lIns="0" tIns="0" rIns="0" bIns="0" rtlCol="0" anchor="ctr"/>
           <a:lstStyle/>
           <a:p>
-            <a:pPr algn="l" indent="0" marL="0">
+            <a:pPr marL="0" indent="0" algn="l">
               <a:buNone/>
             </a:pPr>
             <a:r>
@@ -3686,13 +3650,20 @@
             <a:prstDash val="solid"/>
           </a:ln>
           <a:effectLst>
-            <a:outerShdw sx="100000" sy="100000" kx="0" ky="0" algn="bl" rotWithShape="0" blurRad="88900" dist="25400" dir="2700000">
+            <a:outerShdw blurRad="88900" dist="25400" dir="2700000" algn="bl" rotWithShape="0">
               <a:srgbClr val="000000">
                 <a:alpha val="10000"/>
               </a:srgbClr>
             </a:outerShdw>
           </a:effectLst>
         </p:spPr>
+        <p:txBody>
+          <a:bodyPr/>
+          <a:lstStyle/>
+          <a:p>
+            <a:endParaRPr lang="en-US"/>
+          </a:p>
+        </p:txBody>
       </p:sp>
       <p:sp>
         <p:nvSpPr>
@@ -3715,7 +3686,7 @@
           <a:bodyPr wrap="square" lIns="0" tIns="0" rIns="0" bIns="0" rtlCol="0" anchor="ctr"/>
           <a:lstStyle/>
           <a:p>
-            <a:pPr algn="l" indent="0" marL="0">
+            <a:pPr marL="0" indent="0" algn="l">
               <a:buNone/>
             </a:pPr>
             <a:r>
@@ -3754,7 +3725,7 @@
           <a:bodyPr wrap="square" lIns="0" tIns="0" rIns="0" bIns="0" rtlCol="0" anchor="ctr"/>
           <a:lstStyle/>
           <a:p>
-            <a:pPr algn="l" indent="0" marL="0">
+            <a:pPr marL="0" indent="0" algn="l">
               <a:buNone/>
             </a:pPr>
             <a:r>
@@ -3793,7 +3764,7 @@
           <a:bodyPr wrap="square" lIns="0" tIns="0" rIns="0" bIns="0" rtlCol="0" anchor="t"/>
           <a:lstStyle/>
           <a:p>
-            <a:pPr algn="l" indent="0" marL="0">
+            <a:pPr marL="0" indent="0" algn="l">
               <a:buNone/>
             </a:pPr>
             <a:r>
@@ -3837,13 +3808,20 @@
             <a:prstDash val="solid"/>
           </a:ln>
           <a:effectLst>
-            <a:outerShdw sx="100000" sy="100000" kx="0" ky="0" algn="bl" rotWithShape="0" blurRad="88900" dist="25400" dir="2700000">
+            <a:outerShdw blurRad="88900" dist="25400" dir="2700000" algn="bl" rotWithShape="0">
               <a:srgbClr val="000000">
                 <a:alpha val="10000"/>
               </a:srgbClr>
             </a:outerShdw>
           </a:effectLst>
         </p:spPr>
+        <p:txBody>
+          <a:bodyPr/>
+          <a:lstStyle/>
+          <a:p>
+            <a:endParaRPr lang="en-US"/>
+          </a:p>
+        </p:txBody>
       </p:sp>
       <p:sp>
         <p:nvSpPr>
@@ -3866,7 +3844,7 @@
           <a:bodyPr wrap="square" lIns="0" tIns="0" rIns="0" bIns="0" rtlCol="0" anchor="ctr"/>
           <a:lstStyle/>
           <a:p>
-            <a:pPr algn="l" indent="0" marL="0">
+            <a:pPr marL="0" indent="0" algn="l">
               <a:buNone/>
             </a:pPr>
             <a:r>
@@ -3905,7 +3883,7 @@
           <a:bodyPr wrap="square" lIns="0" tIns="0" rIns="0" bIns="0" rtlCol="0" anchor="ctr"/>
           <a:lstStyle/>
           <a:p>
-            <a:pPr algn="l" indent="0" marL="0">
+            <a:pPr marL="0" indent="0" algn="l">
               <a:buNone/>
             </a:pPr>
             <a:r>
@@ -3944,7 +3922,7 @@
           <a:bodyPr wrap="square" lIns="0" tIns="0" rIns="0" bIns="0" rtlCol="0" anchor="t"/>
           <a:lstStyle/>
           <a:p>
-            <a:pPr algn="l" indent="0" marL="0">
+            <a:pPr marL="0" indent="0" algn="l">
               <a:buNone/>
             </a:pPr>
             <a:r>
@@ -3988,13 +3966,20 @@
             <a:prstDash val="solid"/>
           </a:ln>
           <a:effectLst>
-            <a:outerShdw sx="100000" sy="100000" kx="0" ky="0" algn="bl" rotWithShape="0" blurRad="88900" dist="25400" dir="2700000">
+            <a:outerShdw blurRad="88900" dist="25400" dir="2700000" algn="bl" rotWithShape="0">
               <a:srgbClr val="000000">
                 <a:alpha val="10000"/>
               </a:srgbClr>
             </a:outerShdw>
           </a:effectLst>
         </p:spPr>
+        <p:txBody>
+          <a:bodyPr/>
+          <a:lstStyle/>
+          <a:p>
+            <a:endParaRPr lang="en-US"/>
+          </a:p>
+        </p:txBody>
       </p:sp>
       <p:sp>
         <p:nvSpPr>
@@ -4017,7 +4002,7 @@
           <a:bodyPr wrap="square" lIns="0" tIns="0" rIns="0" bIns="0" rtlCol="0" anchor="ctr"/>
           <a:lstStyle/>
           <a:p>
-            <a:pPr algn="l" indent="0" marL="0">
+            <a:pPr marL="0" indent="0" algn="l">
               <a:buNone/>
             </a:pPr>
             <a:r>
@@ -4056,7 +4041,7 @@
           <a:bodyPr wrap="square" lIns="0" tIns="0" rIns="0" bIns="0" rtlCol="0" anchor="ctr"/>
           <a:lstStyle/>
           <a:p>
-            <a:pPr algn="l" indent="0" marL="0">
+            <a:pPr marL="0" indent="0" algn="l">
               <a:buNone/>
             </a:pPr>
             <a:r>
@@ -4095,7 +4080,7 @@
           <a:bodyPr wrap="square" lIns="0" tIns="0" rIns="0" bIns="0" rtlCol="0" anchor="t"/>
           <a:lstStyle/>
           <a:p>
-            <a:pPr algn="l" indent="0" marL="0">
+            <a:pPr marL="0" indent="0" algn="l">
               <a:buNone/>
             </a:pPr>
             <a:r>
@@ -4139,13 +4124,20 @@
             <a:prstDash val="solid"/>
           </a:ln>
           <a:effectLst>
-            <a:outerShdw sx="100000" sy="100000" kx="0" ky="0" algn="bl" rotWithShape="0" blurRad="88900" dist="25400" dir="2700000">
+            <a:outerShdw blurRad="88900" dist="25400" dir="2700000" algn="bl" rotWithShape="0">
               <a:srgbClr val="000000">
                 <a:alpha val="10000"/>
               </a:srgbClr>
             </a:outerShdw>
           </a:effectLst>
         </p:spPr>
+        <p:txBody>
+          <a:bodyPr/>
+          <a:lstStyle/>
+          <a:p>
+            <a:endParaRPr lang="en-US"/>
+          </a:p>
+        </p:txBody>
       </p:sp>
       <p:sp>
         <p:nvSpPr>
@@ -4168,7 +4160,7 @@
           <a:bodyPr wrap="square" lIns="0" tIns="0" rIns="0" bIns="0" rtlCol="0" anchor="ctr"/>
           <a:lstStyle/>
           <a:p>
-            <a:pPr algn="l" indent="0" marL="0">
+            <a:pPr marL="0" indent="0" algn="l">
               <a:buNone/>
             </a:pPr>
             <a:r>
@@ -4207,7 +4199,7 @@
           <a:bodyPr wrap="square" lIns="0" tIns="0" rIns="0" bIns="0" rtlCol="0" anchor="ctr"/>
           <a:lstStyle/>
           <a:p>
-            <a:pPr algn="l" indent="0" marL="0">
+            <a:pPr marL="0" indent="0" algn="l">
               <a:buNone/>
             </a:pPr>
             <a:r>
@@ -4246,7 +4238,7 @@
           <a:bodyPr wrap="square" lIns="0" tIns="0" rIns="0" bIns="0" rtlCol="0" anchor="t"/>
           <a:lstStyle/>
           <a:p>
-            <a:pPr algn="l" indent="0" marL="0">
+            <a:pPr marL="0" indent="0" algn="l">
               <a:buNone/>
             </a:pPr>
             <a:r>
@@ -4280,6 +4272,7 @@
         <a:solidFill>
           <a:srgbClr val="FFFFFF"/>
         </a:solidFill>
+        <a:effectLst/>
       </p:bgPr>
     </p:bg>
     <p:spTree>
@@ -4317,7 +4310,7 @@
           <a:bodyPr wrap="square" lIns="0" tIns="0" rIns="0" bIns="0" rtlCol="0" anchor="ctr"/>
           <a:lstStyle/>
           <a:p>
-            <a:pPr algn="l" indent="0" marL="0">
+            <a:pPr marL="0" indent="0" algn="l">
               <a:buNone/>
             </a:pPr>
             <a:r>
@@ -4356,7 +4349,7 @@
           <a:bodyPr wrap="square" lIns="0" tIns="0" rIns="0" bIns="0" rtlCol="0" anchor="ctr"/>
           <a:lstStyle/>
           <a:p>
-            <a:pPr algn="l" indent="0" marL="0">
+            <a:pPr marL="0" indent="0" algn="l">
               <a:buNone/>
             </a:pPr>
             <a:r>
@@ -4400,13 +4393,20 @@
             <a:prstDash val="solid"/>
           </a:ln>
           <a:effectLst>
-            <a:outerShdw sx="100000" sy="100000" kx="0" ky="0" algn="bl" rotWithShape="0" blurRad="88900" dist="25400" dir="2700000">
+            <a:outerShdw blurRad="88900" dist="25400" dir="2700000" algn="bl" rotWithShape="0">
               <a:srgbClr val="000000">
                 <a:alpha val="10000"/>
               </a:srgbClr>
             </a:outerShdw>
           </a:effectLst>
         </p:spPr>
+        <p:txBody>
+          <a:bodyPr/>
+          <a:lstStyle/>
+          <a:p>
+            <a:endParaRPr lang="en-US"/>
+          </a:p>
+        </p:txBody>
       </p:sp>
       <p:sp>
         <p:nvSpPr>
@@ -4429,7 +4429,7 @@
           <a:bodyPr wrap="square" lIns="0" tIns="0" rIns="0" bIns="0" rtlCol="0" anchor="ctr"/>
           <a:lstStyle/>
           <a:p>
-            <a:pPr algn="l" indent="0" marL="0">
+            <a:pPr marL="0" indent="0" algn="l">
               <a:buNone/>
             </a:pPr>
             <a:r>
@@ -4468,7 +4468,7 @@
           <a:bodyPr wrap="square" lIns="0" tIns="0" rIns="0" bIns="0" rtlCol="0" anchor="ctr"/>
           <a:lstStyle/>
           <a:p>
-            <a:pPr algn="l" indent="0" marL="0">
+            <a:pPr marL="0" indent="0" algn="l">
               <a:buNone/>
             </a:pPr>
             <a:r>
@@ -4507,7 +4507,7 @@
           <a:bodyPr wrap="square" lIns="0" tIns="0" rIns="0" bIns="0" rtlCol="0" anchor="ctr"/>
           <a:lstStyle/>
           <a:p>
-            <a:pPr algn="l" indent="0" marL="0">
+            <a:pPr marL="0" indent="0" algn="l">
               <a:buNone/>
             </a:pPr>
             <a:r>
@@ -4546,7 +4546,7 @@
           <a:bodyPr wrap="square" lIns="0" tIns="0" rIns="0" bIns="0" rtlCol="0" anchor="ctr"/>
           <a:lstStyle/>
           <a:p>
-            <a:pPr algn="l" indent="0" marL="0">
+            <a:pPr marL="0" indent="0" algn="l">
               <a:buNone/>
             </a:pPr>
             <a:r>
@@ -4590,13 +4590,20 @@
             <a:prstDash val="solid"/>
           </a:ln>
           <a:effectLst>
-            <a:outerShdw sx="100000" sy="100000" kx="0" ky="0" algn="bl" rotWithShape="0" blurRad="88900" dist="25400" dir="2700000">
+            <a:outerShdw blurRad="88900" dist="25400" dir="2700000" algn="bl" rotWithShape="0">
               <a:srgbClr val="000000">
                 <a:alpha val="10000"/>
               </a:srgbClr>
             </a:outerShdw>
           </a:effectLst>
         </p:spPr>
+        <p:txBody>
+          <a:bodyPr/>
+          <a:lstStyle/>
+          <a:p>
+            <a:endParaRPr lang="en-US"/>
+          </a:p>
+        </p:txBody>
       </p:sp>
       <p:sp>
         <p:nvSpPr>
@@ -4619,7 +4626,7 @@
           <a:bodyPr wrap="square" lIns="0" tIns="0" rIns="0" bIns="0" rtlCol="0" anchor="ctr"/>
           <a:lstStyle/>
           <a:p>
-            <a:pPr algn="l" indent="0" marL="0">
+            <a:pPr marL="0" indent="0" algn="l">
               <a:buNone/>
             </a:pPr>
             <a:r>
@@ -4658,7 +4665,7 @@
           <a:bodyPr wrap="square" lIns="0" tIns="0" rIns="0" bIns="0" rtlCol="0" anchor="ctr"/>
           <a:lstStyle/>
           <a:p>
-            <a:pPr algn="l" indent="0" marL="0">
+            <a:pPr marL="0" indent="0" algn="l">
               <a:buNone/>
             </a:pPr>
             <a:r>
@@ -4697,7 +4704,7 @@
           <a:bodyPr wrap="square" lIns="0" tIns="0" rIns="0" bIns="0" rtlCol="0" anchor="ctr"/>
           <a:lstStyle/>
           <a:p>
-            <a:pPr algn="l" indent="0" marL="0">
+            <a:pPr marL="0" indent="0" algn="l">
               <a:buNone/>
             </a:pPr>
             <a:r>
@@ -4736,7 +4743,7 @@
           <a:bodyPr wrap="square" lIns="0" tIns="0" rIns="0" bIns="0" rtlCol="0" anchor="ctr"/>
           <a:lstStyle/>
           <a:p>
-            <a:pPr algn="l" indent="0" marL="0">
+            <a:pPr marL="0" indent="0" algn="l">
               <a:buNone/>
             </a:pPr>
             <a:r>
@@ -4780,13 +4787,20 @@
             <a:prstDash val="solid"/>
           </a:ln>
           <a:effectLst>
-            <a:outerShdw sx="100000" sy="100000" kx="0" ky="0" algn="bl" rotWithShape="0" blurRad="88900" dist="25400" dir="2700000">
+            <a:outerShdw blurRad="88900" dist="25400" dir="2700000" algn="bl" rotWithShape="0">
               <a:srgbClr val="000000">
                 <a:alpha val="10000"/>
               </a:srgbClr>
             </a:outerShdw>
           </a:effectLst>
         </p:spPr>
+        <p:txBody>
+          <a:bodyPr/>
+          <a:lstStyle/>
+          <a:p>
+            <a:endParaRPr lang="en-US"/>
+          </a:p>
+        </p:txBody>
       </p:sp>
       <p:sp>
         <p:nvSpPr>
@@ -4809,7 +4823,7 @@
           <a:bodyPr wrap="square" lIns="0" tIns="0" rIns="0" bIns="0" rtlCol="0" anchor="ctr"/>
           <a:lstStyle/>
           <a:p>
-            <a:pPr algn="l" indent="0" marL="0">
+            <a:pPr marL="0" indent="0" algn="l">
               <a:buNone/>
             </a:pPr>
             <a:r>
@@ -4848,7 +4862,7 @@
           <a:bodyPr wrap="square" lIns="0" tIns="0" rIns="0" bIns="0" rtlCol="0" anchor="ctr"/>
           <a:lstStyle/>
           <a:p>
-            <a:pPr algn="l" indent="0" marL="0">
+            <a:pPr marL="0" indent="0" algn="l">
               <a:buNone/>
             </a:pPr>
             <a:r>
@@ -4887,7 +4901,7 @@
           <a:bodyPr wrap="square" lIns="0" tIns="0" rIns="0" bIns="0" rtlCol="0" anchor="ctr"/>
           <a:lstStyle/>
           <a:p>
-            <a:pPr algn="l" indent="0" marL="0">
+            <a:pPr marL="0" indent="0" algn="l">
               <a:buNone/>
             </a:pPr>
             <a:r>
@@ -4926,7 +4940,7 @@
           <a:bodyPr wrap="square" lIns="0" tIns="0" rIns="0" bIns="0" rtlCol="0" anchor="ctr"/>
           <a:lstStyle/>
           <a:p>
-            <a:pPr algn="l" indent="0" marL="0">
+            <a:pPr marL="0" indent="0" algn="l">
               <a:buNone/>
             </a:pPr>
             <a:r>
@@ -4970,13 +4984,20 @@
             <a:prstDash val="solid"/>
           </a:ln>
           <a:effectLst>
-            <a:outerShdw sx="100000" sy="100000" kx="0" ky="0" algn="bl" rotWithShape="0" blurRad="88900" dist="25400" dir="2700000">
+            <a:outerShdw blurRad="88900" dist="25400" dir="2700000" algn="bl" rotWithShape="0">
               <a:srgbClr val="000000">
                 <a:alpha val="10000"/>
               </a:srgbClr>
             </a:outerShdw>
           </a:effectLst>
         </p:spPr>
+        <p:txBody>
+          <a:bodyPr/>
+          <a:lstStyle/>
+          <a:p>
+            <a:endParaRPr lang="en-US"/>
+          </a:p>
+        </p:txBody>
       </p:sp>
       <p:sp>
         <p:nvSpPr>
@@ -4999,7 +5020,7 @@
           <a:bodyPr wrap="square" lIns="0" tIns="0" rIns="0" bIns="0" rtlCol="0" anchor="ctr"/>
           <a:lstStyle/>
           <a:p>
-            <a:pPr algn="l" indent="0" marL="0">
+            <a:pPr marL="0" indent="0" algn="l">
               <a:buNone/>
             </a:pPr>
             <a:r>
@@ -5038,7 +5059,7 @@
           <a:bodyPr wrap="square" lIns="0" tIns="0" rIns="0" bIns="0" rtlCol="0" anchor="ctr"/>
           <a:lstStyle/>
           <a:p>
-            <a:pPr algn="l" indent="0" marL="0">
+            <a:pPr marL="0" indent="0" algn="l">
               <a:buNone/>
             </a:pPr>
             <a:r>
@@ -5077,7 +5098,7 @@
           <a:bodyPr wrap="square" lIns="0" tIns="0" rIns="0" bIns="0" rtlCol="0" anchor="ctr"/>
           <a:lstStyle/>
           <a:p>
-            <a:pPr algn="l" indent="0" marL="0">
+            <a:pPr marL="0" indent="0" algn="l">
               <a:buNone/>
             </a:pPr>
             <a:r>
@@ -5116,7 +5137,7 @@
           <a:bodyPr wrap="square" lIns="0" tIns="0" rIns="0" bIns="0" rtlCol="0" anchor="ctr"/>
           <a:lstStyle/>
           <a:p>
-            <a:pPr algn="l" indent="0" marL="0">
+            <a:pPr marL="0" indent="0" algn="l">
               <a:buNone/>
             </a:pPr>
             <a:r>
@@ -5150,6 +5171,7 @@
         <a:solidFill>
           <a:srgbClr val="FFFFFF"/>
         </a:solidFill>
+        <a:effectLst/>
       </p:bgPr>
     </p:bg>
     <p:spTree>
@@ -5187,7 +5209,7 @@
           <a:bodyPr wrap="square" lIns="0" tIns="0" rIns="0" bIns="0" rtlCol="0" anchor="ctr"/>
           <a:lstStyle/>
           <a:p>
-            <a:pPr algn="l" indent="0" marL="0">
+            <a:pPr marL="0" indent="0" algn="l">
               <a:buNone/>
             </a:pPr>
             <a:r>
@@ -5221,18 +5243,48 @@
         </p:nvGraphicFramePr>
         <p:xfrm>
           <a:off x="320040" y="841248"/>
-          <a:ext cx="8503920" cy="914400"/>
+          <a:ext cx="8503920" cy="3584448"/>
         </p:xfrm>
         <a:graphic>
           <a:graphicData uri="http://schemas.openxmlformats.org/drawingml/2006/table">
             <a:tbl>
               <a:tblPr/>
               <a:tblGrid>
-                <a:gridCol w="2606040"/>
-                <a:gridCol w="1316736"/>
-                <a:gridCol w="1316736"/>
-                <a:gridCol w="1316736"/>
-                <a:gridCol w="1947672"/>
+                <a:gridCol w="2606040">
+                  <a:extLst>
+                    <a:ext uri="{9D8B030D-6E8A-4147-A177-3AD203B41FA5}">
+                      <a16:colId xmlns:a16="http://schemas.microsoft.com/office/drawing/2014/main" val="20000"/>
+                    </a:ext>
+                  </a:extLst>
+                </a:gridCol>
+                <a:gridCol w="1316736">
+                  <a:extLst>
+                    <a:ext uri="{9D8B030D-6E8A-4147-A177-3AD203B41FA5}">
+                      <a16:colId xmlns:a16="http://schemas.microsoft.com/office/drawing/2014/main" val="20001"/>
+                    </a:ext>
+                  </a:extLst>
+                </a:gridCol>
+                <a:gridCol w="1316736">
+                  <a:extLst>
+                    <a:ext uri="{9D8B030D-6E8A-4147-A177-3AD203B41FA5}">
+                      <a16:colId xmlns:a16="http://schemas.microsoft.com/office/drawing/2014/main" val="20002"/>
+                    </a:ext>
+                  </a:extLst>
+                </a:gridCol>
+                <a:gridCol w="1316736">
+                  <a:extLst>
+                    <a:ext uri="{9D8B030D-6E8A-4147-A177-3AD203B41FA5}">
+                      <a16:colId xmlns:a16="http://schemas.microsoft.com/office/drawing/2014/main" val="20003"/>
+                    </a:ext>
+                  </a:extLst>
+                </a:gridCol>
+                <a:gridCol w="1947672">
+                  <a:extLst>
+                    <a:ext uri="{9D8B030D-6E8A-4147-A177-3AD203B41FA5}">
+                      <a16:colId xmlns:a16="http://schemas.microsoft.com/office/drawing/2014/main" val="20004"/>
+                    </a:ext>
+                  </a:extLst>
+                </a:gridCol>
               </a:tblGrid>
               <a:tr h="512064">
                 <a:tc>
@@ -5240,7 +5292,7 @@
                     <a:bodyPr/>
                     <a:lstStyle/>
                     <a:p>
-                      <a:pPr algn="ctr" indent="0" marL="0">
+                      <a:pPr marL="0" indent="0" algn="ctr">
                         <a:buNone/>
                       </a:pPr>
                       <a:r>
@@ -5261,7 +5313,7 @@
                       </a:endParaRPr>
                     </a:p>
                   </a:txBody>
-                  <a:tcPr marL="91440" marR="91440" marT="45720" marB="45720">
+                  <a:tcPr>
                     <a:lnL w="6350" cap="flat" cmpd="sng" algn="ctr">
                       <a:solidFill>
                         <a:srgbClr val="C4B9AC"/>
@@ -5308,7 +5360,7 @@
                     <a:bodyPr/>
                     <a:lstStyle/>
                     <a:p>
-                      <a:pPr algn="ctr" indent="0" marL="0">
+                      <a:pPr marL="0" indent="0" algn="ctr">
                         <a:buNone/>
                       </a:pPr>
                       <a:r>
@@ -5329,7 +5381,7 @@
                       </a:endParaRPr>
                     </a:p>
                   </a:txBody>
-                  <a:tcPr marL="91440" marR="91440" marT="45720" marB="45720">
+                  <a:tcPr>
                     <a:lnL w="6350" cap="flat" cmpd="sng" algn="ctr">
                       <a:solidFill>
                         <a:srgbClr val="C4B9AC"/>
@@ -5376,7 +5428,7 @@
                     <a:bodyPr/>
                     <a:lstStyle/>
                     <a:p>
-                      <a:pPr algn="ctr" indent="0" marL="0">
+                      <a:pPr marL="0" indent="0" algn="ctr">
                         <a:buNone/>
                       </a:pPr>
                       <a:r>
@@ -5397,7 +5449,7 @@
                       </a:endParaRPr>
                     </a:p>
                   </a:txBody>
-                  <a:tcPr marL="91440" marR="91440" marT="45720" marB="45720">
+                  <a:tcPr>
                     <a:lnL w="6350" cap="flat" cmpd="sng" algn="ctr">
                       <a:solidFill>
                         <a:srgbClr val="C4B9AC"/>
@@ -5444,7 +5496,7 @@
                     <a:bodyPr/>
                     <a:lstStyle/>
                     <a:p>
-                      <a:pPr algn="ctr" indent="0" marL="0">
+                      <a:pPr marL="0" indent="0" algn="ctr">
                         <a:buNone/>
                       </a:pPr>
                       <a:r>
@@ -5465,7 +5517,7 @@
                       </a:endParaRPr>
                     </a:p>
                   </a:txBody>
-                  <a:tcPr marL="91440" marR="91440" marT="45720" marB="45720">
+                  <a:tcPr>
                     <a:lnL w="6350" cap="flat" cmpd="sng" algn="ctr">
                       <a:solidFill>
                         <a:srgbClr val="C4B9AC"/>
@@ -5512,7 +5564,7 @@
                     <a:bodyPr/>
                     <a:lstStyle/>
                     <a:p>
-                      <a:pPr algn="ctr" indent="0" marL="0">
+                      <a:pPr marL="0" indent="0" algn="ctr">
                         <a:buNone/>
                       </a:pPr>
                       <a:r>
@@ -5533,7 +5585,7 @@
                       </a:endParaRPr>
                     </a:p>
                   </a:txBody>
-                  <a:tcPr marL="91440" marR="91440" marT="45720" marB="45720">
+                  <a:tcPr>
                     <a:lnL w="6350" cap="flat" cmpd="sng" algn="ctr">
                       <a:solidFill>
                         <a:srgbClr val="C4B9AC"/>
@@ -5575,6 +5627,11 @@
                     </a:solidFill>
                   </a:tcPr>
                 </a:tc>
+                <a:extLst>
+                  <a:ext uri="{0D108BD9-81ED-4DB2-BD59-A6C34878D82A}">
+                    <a16:rowId xmlns:a16="http://schemas.microsoft.com/office/drawing/2014/main" val="10000"/>
+                  </a:ext>
+                </a:extLst>
               </a:tr>
               <a:tr h="512064">
                 <a:tc>
@@ -5582,7 +5639,7 @@
                     <a:bodyPr/>
                     <a:lstStyle/>
                     <a:p>
-                      <a:pPr algn="l" indent="0" marL="0">
+                      <a:pPr marL="0" indent="0" algn="l">
                         <a:buNone/>
                       </a:pPr>
                       <a:r>
@@ -5603,7 +5660,7 @@
                       </a:endParaRPr>
                     </a:p>
                   </a:txBody>
-                  <a:tcPr marL="91440" marR="91440" marT="45720" marB="45720">
+                  <a:tcPr>
                     <a:lnL w="6350" cap="flat" cmpd="sng" algn="ctr">
                       <a:solidFill>
                         <a:srgbClr val="C4B9AC"/>
@@ -5650,7 +5707,7 @@
                     <a:bodyPr/>
                     <a:lstStyle/>
                     <a:p>
-                      <a:pPr algn="ctr" indent="0" marL="0">
+                      <a:pPr marL="0" indent="0" algn="ctr">
                         <a:buNone/>
                       </a:pPr>
                       <a:r>
@@ -5671,7 +5728,7 @@
                       </a:endParaRPr>
                     </a:p>
                   </a:txBody>
-                  <a:tcPr marL="91440" marR="91440" marT="45720" marB="45720">
+                  <a:tcPr>
                     <a:lnL w="6350" cap="flat" cmpd="sng" algn="ctr">
                       <a:solidFill>
                         <a:srgbClr val="C4B9AC"/>
@@ -5718,7 +5775,7 @@
                     <a:bodyPr/>
                     <a:lstStyle/>
                     <a:p>
-                      <a:pPr algn="ctr" indent="0" marL="0">
+                      <a:pPr marL="0" indent="0" algn="ctr">
                         <a:buNone/>
                       </a:pPr>
                       <a:r>
@@ -5739,7 +5796,7 @@
                       </a:endParaRPr>
                     </a:p>
                   </a:txBody>
-                  <a:tcPr marL="91440" marR="91440" marT="45720" marB="45720">
+                  <a:tcPr>
                     <a:lnL w="6350" cap="flat" cmpd="sng" algn="ctr">
                       <a:solidFill>
                         <a:srgbClr val="C4B9AC"/>
@@ -5786,7 +5843,7 @@
                     <a:bodyPr/>
                     <a:lstStyle/>
                     <a:p>
-                      <a:pPr algn="ctr" indent="0" marL="0">
+                      <a:pPr marL="0" indent="0" algn="ctr">
                         <a:buNone/>
                       </a:pPr>
                       <a:r>
@@ -5807,7 +5864,7 @@
                       </a:endParaRPr>
                     </a:p>
                   </a:txBody>
-                  <a:tcPr marL="91440" marR="91440" marT="45720" marB="45720">
+                  <a:tcPr>
                     <a:lnL w="6350" cap="flat" cmpd="sng" algn="ctr">
                       <a:solidFill>
                         <a:srgbClr val="C4B9AC"/>
@@ -5854,7 +5911,7 @@
                     <a:bodyPr/>
                     <a:lstStyle/>
                     <a:p>
-                      <a:pPr algn="ctr" indent="0" marL="0">
+                      <a:pPr marL="0" indent="0" algn="ctr">
                         <a:buNone/>
                       </a:pPr>
                       <a:r>
@@ -5875,7 +5932,7 @@
                       </a:endParaRPr>
                     </a:p>
                   </a:txBody>
-                  <a:tcPr marL="91440" marR="91440" marT="45720" marB="45720">
+                  <a:tcPr>
                     <a:lnL w="6350" cap="flat" cmpd="sng" algn="ctr">
                       <a:solidFill>
                         <a:srgbClr val="C4B9AC"/>
@@ -5917,6 +5974,11 @@
                     </a:solidFill>
                   </a:tcPr>
                 </a:tc>
+                <a:extLst>
+                  <a:ext uri="{0D108BD9-81ED-4DB2-BD59-A6C34878D82A}">
+                    <a16:rowId xmlns:a16="http://schemas.microsoft.com/office/drawing/2014/main" val="10001"/>
+                  </a:ext>
+                </a:extLst>
               </a:tr>
               <a:tr h="512064">
                 <a:tc>
@@ -5924,7 +5986,7 @@
                     <a:bodyPr/>
                     <a:lstStyle/>
                     <a:p>
-                      <a:pPr algn="l" indent="0" marL="0">
+                      <a:pPr marL="0" indent="0" algn="l">
                         <a:buNone/>
                       </a:pPr>
                       <a:r>
@@ -5945,7 +6007,7 @@
                       </a:endParaRPr>
                     </a:p>
                   </a:txBody>
-                  <a:tcPr marL="91440" marR="91440" marT="45720" marB="45720">
+                  <a:tcPr>
                     <a:lnL w="6350" cap="flat" cmpd="sng" algn="ctr">
                       <a:solidFill>
                         <a:srgbClr val="C4B9AC"/>
@@ -5992,7 +6054,7 @@
                     <a:bodyPr/>
                     <a:lstStyle/>
                     <a:p>
-                      <a:pPr algn="ctr" indent="0" marL="0">
+                      <a:pPr marL="0" indent="0" algn="ctr">
                         <a:buNone/>
                       </a:pPr>
                       <a:r>
@@ -6013,7 +6075,7 @@
                       </a:endParaRPr>
                     </a:p>
                   </a:txBody>
-                  <a:tcPr marL="91440" marR="91440" marT="45720" marB="45720">
+                  <a:tcPr>
                     <a:lnL w="6350" cap="flat" cmpd="sng" algn="ctr">
                       <a:solidFill>
                         <a:srgbClr val="C4B9AC"/>
@@ -6060,7 +6122,7 @@
                     <a:bodyPr/>
                     <a:lstStyle/>
                     <a:p>
-                      <a:pPr algn="ctr" indent="0" marL="0">
+                      <a:pPr marL="0" indent="0" algn="ctr">
                         <a:buNone/>
                       </a:pPr>
                       <a:r>
@@ -6081,7 +6143,7 @@
                       </a:endParaRPr>
                     </a:p>
                   </a:txBody>
-                  <a:tcPr marL="91440" marR="91440" marT="45720" marB="45720">
+                  <a:tcPr>
                     <a:lnL w="6350" cap="flat" cmpd="sng" algn="ctr">
                       <a:solidFill>
                         <a:srgbClr val="C4B9AC"/>
@@ -6128,7 +6190,7 @@
                     <a:bodyPr/>
                     <a:lstStyle/>
                     <a:p>
-                      <a:pPr algn="ctr" indent="0" marL="0">
+                      <a:pPr marL="0" indent="0" algn="ctr">
                         <a:buNone/>
                       </a:pPr>
                       <a:r>
@@ -6149,7 +6211,7 @@
                       </a:endParaRPr>
                     </a:p>
                   </a:txBody>
-                  <a:tcPr marL="91440" marR="91440" marT="45720" marB="45720">
+                  <a:tcPr>
                     <a:lnL w="6350" cap="flat" cmpd="sng" algn="ctr">
                       <a:solidFill>
                         <a:srgbClr val="C4B9AC"/>
@@ -6196,7 +6258,7 @@
                     <a:bodyPr/>
                     <a:lstStyle/>
                     <a:p>
-                      <a:pPr algn="ctr" indent="0" marL="0">
+                      <a:pPr marL="0" indent="0" algn="ctr">
                         <a:buNone/>
                       </a:pPr>
                       <a:r>
@@ -6217,7 +6279,7 @@
                       </a:endParaRPr>
                     </a:p>
                   </a:txBody>
-                  <a:tcPr marL="91440" marR="91440" marT="45720" marB="45720">
+                  <a:tcPr>
                     <a:lnL w="6350" cap="flat" cmpd="sng" algn="ctr">
                       <a:solidFill>
                         <a:srgbClr val="C4B9AC"/>
@@ -6259,6 +6321,11 @@
                     </a:solidFill>
                   </a:tcPr>
                 </a:tc>
+                <a:extLst>
+                  <a:ext uri="{0D108BD9-81ED-4DB2-BD59-A6C34878D82A}">
+                    <a16:rowId xmlns:a16="http://schemas.microsoft.com/office/drawing/2014/main" val="10002"/>
+                  </a:ext>
+                </a:extLst>
               </a:tr>
               <a:tr h="512064">
                 <a:tc>
@@ -6266,7 +6333,7 @@
                     <a:bodyPr/>
                     <a:lstStyle/>
                     <a:p>
-                      <a:pPr algn="l" indent="0" marL="0">
+                      <a:pPr marL="0" indent="0" algn="l">
                         <a:buNone/>
                       </a:pPr>
                       <a:r>
@@ -6287,7 +6354,7 @@
                       </a:endParaRPr>
                     </a:p>
                   </a:txBody>
-                  <a:tcPr marL="91440" marR="91440" marT="45720" marB="45720">
+                  <a:tcPr>
                     <a:lnL w="6350" cap="flat" cmpd="sng" algn="ctr">
                       <a:solidFill>
                         <a:srgbClr val="C4B9AC"/>
@@ -6334,7 +6401,7 @@
                     <a:bodyPr/>
                     <a:lstStyle/>
                     <a:p>
-                      <a:pPr algn="ctr" indent="0" marL="0">
+                      <a:pPr marL="0" indent="0" algn="ctr">
                         <a:buNone/>
                       </a:pPr>
                       <a:r>
@@ -6355,7 +6422,7 @@
                       </a:endParaRPr>
                     </a:p>
                   </a:txBody>
-                  <a:tcPr marL="91440" marR="91440" marT="45720" marB="45720">
+                  <a:tcPr>
                     <a:lnL w="6350" cap="flat" cmpd="sng" algn="ctr">
                       <a:solidFill>
                         <a:srgbClr val="C4B9AC"/>
@@ -6402,7 +6469,7 @@
                     <a:bodyPr/>
                     <a:lstStyle/>
                     <a:p>
-                      <a:pPr algn="ctr" indent="0" marL="0">
+                      <a:pPr marL="0" indent="0" algn="ctr">
                         <a:buNone/>
                       </a:pPr>
                       <a:r>
@@ -6423,7 +6490,7 @@
                       </a:endParaRPr>
                     </a:p>
                   </a:txBody>
-                  <a:tcPr marL="91440" marR="91440" marT="45720" marB="45720">
+                  <a:tcPr>
                     <a:lnL w="6350" cap="flat" cmpd="sng" algn="ctr">
                       <a:solidFill>
                         <a:srgbClr val="C4B9AC"/>
@@ -6470,7 +6537,7 @@
                     <a:bodyPr/>
                     <a:lstStyle/>
                     <a:p>
-                      <a:pPr algn="ctr" indent="0" marL="0">
+                      <a:pPr marL="0" indent="0" algn="ctr">
                         <a:buNone/>
                       </a:pPr>
                       <a:r>
@@ -6491,7 +6558,7 @@
                       </a:endParaRPr>
                     </a:p>
                   </a:txBody>
-                  <a:tcPr marL="91440" marR="91440" marT="45720" marB="45720">
+                  <a:tcPr>
                     <a:lnL w="6350" cap="flat" cmpd="sng" algn="ctr">
                       <a:solidFill>
                         <a:srgbClr val="C4B9AC"/>
@@ -6538,7 +6605,7 @@
                     <a:bodyPr/>
                     <a:lstStyle/>
                     <a:p>
-                      <a:pPr algn="ctr" indent="0" marL="0">
+                      <a:pPr marL="0" indent="0" algn="ctr">
                         <a:buNone/>
                       </a:pPr>
                       <a:r>
@@ -6559,7 +6626,7 @@
                       </a:endParaRPr>
                     </a:p>
                   </a:txBody>
-                  <a:tcPr marL="91440" marR="91440" marT="45720" marB="45720">
+                  <a:tcPr>
                     <a:lnL w="6350" cap="flat" cmpd="sng" algn="ctr">
                       <a:solidFill>
                         <a:srgbClr val="C4B9AC"/>
@@ -6601,6 +6668,11 @@
                     </a:solidFill>
                   </a:tcPr>
                 </a:tc>
+                <a:extLst>
+                  <a:ext uri="{0D108BD9-81ED-4DB2-BD59-A6C34878D82A}">
+                    <a16:rowId xmlns:a16="http://schemas.microsoft.com/office/drawing/2014/main" val="10003"/>
+                  </a:ext>
+                </a:extLst>
               </a:tr>
               <a:tr h="512064">
                 <a:tc>
@@ -6608,7 +6680,7 @@
                     <a:bodyPr/>
                     <a:lstStyle/>
                     <a:p>
-                      <a:pPr algn="l" indent="0" marL="0">
+                      <a:pPr marL="0" indent="0" algn="l">
                         <a:buNone/>
                       </a:pPr>
                       <a:r>
@@ -6629,7 +6701,7 @@
                       </a:endParaRPr>
                     </a:p>
                   </a:txBody>
-                  <a:tcPr marL="91440" marR="91440" marT="45720" marB="45720">
+                  <a:tcPr>
                     <a:lnL w="6350" cap="flat" cmpd="sng" algn="ctr">
                       <a:solidFill>
                         <a:srgbClr val="C4B9AC"/>
@@ -6676,7 +6748,7 @@
                     <a:bodyPr/>
                     <a:lstStyle/>
                     <a:p>
-                      <a:pPr algn="ctr" indent="0" marL="0">
+                      <a:pPr marL="0" indent="0" algn="ctr">
                         <a:buNone/>
                       </a:pPr>
                       <a:r>
@@ -6697,7 +6769,7 @@
                       </a:endParaRPr>
                     </a:p>
                   </a:txBody>
-                  <a:tcPr marL="91440" marR="91440" marT="45720" marB="45720">
+                  <a:tcPr>
                     <a:lnL w="6350" cap="flat" cmpd="sng" algn="ctr">
                       <a:solidFill>
                         <a:srgbClr val="C4B9AC"/>
@@ -6744,7 +6816,7 @@
                     <a:bodyPr/>
                     <a:lstStyle/>
                     <a:p>
-                      <a:pPr algn="ctr" indent="0" marL="0">
+                      <a:pPr marL="0" indent="0" algn="ctr">
                         <a:buNone/>
                       </a:pPr>
                       <a:r>
@@ -6765,7 +6837,7 @@
                       </a:endParaRPr>
                     </a:p>
                   </a:txBody>
-                  <a:tcPr marL="91440" marR="91440" marT="45720" marB="45720">
+                  <a:tcPr>
                     <a:lnL w="6350" cap="flat" cmpd="sng" algn="ctr">
                       <a:solidFill>
                         <a:srgbClr val="C4B9AC"/>
@@ -6812,7 +6884,7 @@
                     <a:bodyPr/>
                     <a:lstStyle/>
                     <a:p>
-                      <a:pPr algn="ctr" indent="0" marL="0">
+                      <a:pPr marL="0" indent="0" algn="ctr">
                         <a:buNone/>
                       </a:pPr>
                       <a:r>
@@ -6833,7 +6905,7 @@
                       </a:endParaRPr>
                     </a:p>
                   </a:txBody>
-                  <a:tcPr marL="91440" marR="91440" marT="45720" marB="45720">
+                  <a:tcPr>
                     <a:lnL w="6350" cap="flat" cmpd="sng" algn="ctr">
                       <a:solidFill>
                         <a:srgbClr val="C4B9AC"/>
@@ -6880,7 +6952,7 @@
                     <a:bodyPr/>
                     <a:lstStyle/>
                     <a:p>
-                      <a:pPr algn="ctr" indent="0" marL="0">
+                      <a:pPr marL="0" indent="0" algn="ctr">
                         <a:buNone/>
                       </a:pPr>
                       <a:r>
@@ -6901,7 +6973,7 @@
                       </a:endParaRPr>
                     </a:p>
                   </a:txBody>
-                  <a:tcPr marL="91440" marR="91440" marT="45720" marB="45720">
+                  <a:tcPr>
                     <a:lnL w="6350" cap="flat" cmpd="sng" algn="ctr">
                       <a:solidFill>
                         <a:srgbClr val="C4B9AC"/>
@@ -6943,6 +7015,11 @@
                     </a:solidFill>
                   </a:tcPr>
                 </a:tc>
+                <a:extLst>
+                  <a:ext uri="{0D108BD9-81ED-4DB2-BD59-A6C34878D82A}">
+                    <a16:rowId xmlns:a16="http://schemas.microsoft.com/office/drawing/2014/main" val="10004"/>
+                  </a:ext>
+                </a:extLst>
               </a:tr>
               <a:tr h="512064">
                 <a:tc>
@@ -6950,7 +7027,7 @@
                     <a:bodyPr/>
                     <a:lstStyle/>
                     <a:p>
-                      <a:pPr algn="l" indent="0" marL="0">
+                      <a:pPr marL="0" indent="0" algn="l">
                         <a:buNone/>
                       </a:pPr>
                       <a:r>
@@ -6971,7 +7048,7 @@
                       </a:endParaRPr>
                     </a:p>
                   </a:txBody>
-                  <a:tcPr marL="91440" marR="91440" marT="45720" marB="45720">
+                  <a:tcPr>
                     <a:lnL w="6350" cap="flat" cmpd="sng" algn="ctr">
                       <a:solidFill>
                         <a:srgbClr val="C4B9AC"/>
@@ -7018,7 +7095,7 @@
                     <a:bodyPr/>
                     <a:lstStyle/>
                     <a:p>
-                      <a:pPr algn="ctr" indent="0" marL="0">
+                      <a:pPr marL="0" indent="0" algn="ctr">
                         <a:buNone/>
                       </a:pPr>
                       <a:r>
@@ -7039,7 +7116,7 @@
                       </a:endParaRPr>
                     </a:p>
                   </a:txBody>
-                  <a:tcPr marL="91440" marR="91440" marT="45720" marB="45720">
+                  <a:tcPr>
                     <a:lnL w="6350" cap="flat" cmpd="sng" algn="ctr">
                       <a:solidFill>
                         <a:srgbClr val="C4B9AC"/>
@@ -7086,7 +7163,7 @@
                     <a:bodyPr/>
                     <a:lstStyle/>
                     <a:p>
-                      <a:pPr algn="ctr" indent="0" marL="0">
+                      <a:pPr marL="0" indent="0" algn="ctr">
                         <a:buNone/>
                       </a:pPr>
                       <a:r>
@@ -7107,7 +7184,7 @@
                       </a:endParaRPr>
                     </a:p>
                   </a:txBody>
-                  <a:tcPr marL="91440" marR="91440" marT="45720" marB="45720">
+                  <a:tcPr>
                     <a:lnL w="6350" cap="flat" cmpd="sng" algn="ctr">
                       <a:solidFill>
                         <a:srgbClr val="C4B9AC"/>
@@ -7154,7 +7231,7 @@
                     <a:bodyPr/>
                     <a:lstStyle/>
                     <a:p>
-                      <a:pPr algn="ctr" indent="0" marL="0">
+                      <a:pPr marL="0" indent="0" algn="ctr">
                         <a:buNone/>
                       </a:pPr>
                       <a:r>
@@ -7175,7 +7252,7 @@
                       </a:endParaRPr>
                     </a:p>
                   </a:txBody>
-                  <a:tcPr marL="91440" marR="91440" marT="45720" marB="45720">
+                  <a:tcPr>
                     <a:lnL w="6350" cap="flat" cmpd="sng" algn="ctr">
                       <a:solidFill>
                         <a:srgbClr val="C4B9AC"/>
@@ -7222,7 +7299,7 @@
                     <a:bodyPr/>
                     <a:lstStyle/>
                     <a:p>
-                      <a:pPr algn="ctr" indent="0" marL="0">
+                      <a:pPr marL="0" indent="0" algn="ctr">
                         <a:buNone/>
                       </a:pPr>
                       <a:r>
@@ -7243,7 +7320,7 @@
                       </a:endParaRPr>
                     </a:p>
                   </a:txBody>
-                  <a:tcPr marL="91440" marR="91440" marT="45720" marB="45720">
+                  <a:tcPr>
                     <a:lnL w="6350" cap="flat" cmpd="sng" algn="ctr">
                       <a:solidFill>
                         <a:srgbClr val="C4B9AC"/>
@@ -7285,6 +7362,11 @@
                     </a:solidFill>
                   </a:tcPr>
                 </a:tc>
+                <a:extLst>
+                  <a:ext uri="{0D108BD9-81ED-4DB2-BD59-A6C34878D82A}">
+                    <a16:rowId xmlns:a16="http://schemas.microsoft.com/office/drawing/2014/main" val="10005"/>
+                  </a:ext>
+                </a:extLst>
               </a:tr>
               <a:tr h="512064">
                 <a:tc>
@@ -7292,7 +7374,7 @@
                     <a:bodyPr/>
                     <a:lstStyle/>
                     <a:p>
-                      <a:pPr algn="l" indent="0" marL="0">
+                      <a:pPr marL="0" indent="0" algn="l">
                         <a:buNone/>
                       </a:pPr>
                       <a:r>
@@ -7313,7 +7395,7 @@
                       </a:endParaRPr>
                     </a:p>
                   </a:txBody>
-                  <a:tcPr marL="91440" marR="91440" marT="45720" marB="45720">
+                  <a:tcPr>
                     <a:lnL w="6350" cap="flat" cmpd="sng" algn="ctr">
                       <a:solidFill>
                         <a:srgbClr val="C4B9AC"/>
@@ -7360,7 +7442,7 @@
                     <a:bodyPr/>
                     <a:lstStyle/>
                     <a:p>
-                      <a:pPr algn="ctr" indent="0" marL="0">
+                      <a:pPr marL="0" indent="0" algn="ctr">
                         <a:buNone/>
                       </a:pPr>
                       <a:r>
@@ -7381,7 +7463,7 @@
                       </a:endParaRPr>
                     </a:p>
                   </a:txBody>
-                  <a:tcPr marL="91440" marR="91440" marT="45720" marB="45720">
+                  <a:tcPr>
                     <a:lnL w="6350" cap="flat" cmpd="sng" algn="ctr">
                       <a:solidFill>
                         <a:srgbClr val="C4B9AC"/>
@@ -7428,7 +7510,7 @@
                     <a:bodyPr/>
                     <a:lstStyle/>
                     <a:p>
-                      <a:pPr algn="ctr" indent="0" marL="0">
+                      <a:pPr marL="0" indent="0" algn="ctr">
                         <a:buNone/>
                       </a:pPr>
                       <a:r>
@@ -7449,7 +7531,7 @@
                       </a:endParaRPr>
                     </a:p>
                   </a:txBody>
-                  <a:tcPr marL="91440" marR="91440" marT="45720" marB="45720">
+                  <a:tcPr>
                     <a:lnL w="6350" cap="flat" cmpd="sng" algn="ctr">
                       <a:solidFill>
                         <a:srgbClr val="C4B9AC"/>
@@ -7496,7 +7578,7 @@
                     <a:bodyPr/>
                     <a:lstStyle/>
                     <a:p>
-                      <a:pPr algn="ctr" indent="0" marL="0">
+                      <a:pPr marL="0" indent="0" algn="ctr">
                         <a:buNone/>
                       </a:pPr>
                       <a:r>
@@ -7517,7 +7599,7 @@
                       </a:endParaRPr>
                     </a:p>
                   </a:txBody>
-                  <a:tcPr marL="91440" marR="91440" marT="45720" marB="45720">
+                  <a:tcPr>
                     <a:lnL w="6350" cap="flat" cmpd="sng" algn="ctr">
                       <a:solidFill>
                         <a:srgbClr val="C4B9AC"/>
@@ -7564,7 +7646,7 @@
                     <a:bodyPr/>
                     <a:lstStyle/>
                     <a:p>
-                      <a:pPr algn="ctr" indent="0" marL="0">
+                      <a:pPr marL="0" indent="0" algn="ctr">
                         <a:buNone/>
                       </a:pPr>
                       <a:r>
@@ -7585,7 +7667,7 @@
                       </a:endParaRPr>
                     </a:p>
                   </a:txBody>
-                  <a:tcPr marL="91440" marR="91440" marT="45720" marB="45720">
+                  <a:tcPr>
                     <a:lnL w="6350" cap="flat" cmpd="sng" algn="ctr">
                       <a:solidFill>
                         <a:srgbClr val="C4B9AC"/>
@@ -7627,6 +7709,11 @@
                     </a:solidFill>
                   </a:tcPr>
                 </a:tc>
+                <a:extLst>
+                  <a:ext uri="{0D108BD9-81ED-4DB2-BD59-A6C34878D82A}">
+                    <a16:rowId xmlns:a16="http://schemas.microsoft.com/office/drawing/2014/main" val="10006"/>
+                  </a:ext>
+                </a:extLst>
               </a:tr>
             </a:tbl>
           </a:graphicData>
@@ -7648,6 +7735,7 @@
         <a:solidFill>
           <a:srgbClr val="FFFFFF"/>
         </a:solidFill>
+        <a:effectLst/>
       </p:bgPr>
     </p:bg>
     <p:spTree>
@@ -7685,7 +7773,7 @@
           <a:bodyPr wrap="square" lIns="0" tIns="0" rIns="0" bIns="0" rtlCol="0" anchor="ctr"/>
           <a:lstStyle/>
           <a:p>
-            <a:pPr algn="l" indent="0" marL="0">
+            <a:pPr marL="0" indent="0" algn="l">
               <a:buNone/>
             </a:pPr>
             <a:r>
@@ -7727,6 +7815,13 @@
             <a:prstDash val="solid"/>
           </a:ln>
         </p:spPr>
+        <p:txBody>
+          <a:bodyPr/>
+          <a:lstStyle/>
+          <a:p>
+            <a:endParaRPr lang="en-US"/>
+          </a:p>
+        </p:txBody>
       </p:sp>
       <p:sp>
         <p:nvSpPr>
@@ -7749,7 +7844,7 @@
           <a:bodyPr wrap="square" lIns="0" tIns="0" rIns="0" bIns="0" rtlCol="0" anchor="ctr"/>
           <a:lstStyle/>
           <a:p>
-            <a:pPr algn="ctr" indent="0" marL="0">
+            <a:pPr marL="0" indent="0" algn="ctr">
               <a:buNone/>
             </a:pPr>
             <a:r>
@@ -7793,13 +7888,20 @@
             <a:prstDash val="solid"/>
           </a:ln>
           <a:effectLst>
-            <a:outerShdw sx="100000" sy="100000" kx="0" ky="0" algn="bl" rotWithShape="0" blurRad="88900" dist="25400" dir="2700000">
+            <a:outerShdw blurRad="88900" dist="25400" dir="2700000" algn="bl" rotWithShape="0">
               <a:srgbClr val="000000">
                 <a:alpha val="10000"/>
               </a:srgbClr>
             </a:outerShdw>
           </a:effectLst>
         </p:spPr>
+        <p:txBody>
+          <a:bodyPr/>
+          <a:lstStyle/>
+          <a:p>
+            <a:endParaRPr lang="en-US"/>
+          </a:p>
+        </p:txBody>
       </p:sp>
       <p:sp>
         <p:nvSpPr>
@@ -7822,7 +7924,7 @@
           <a:bodyPr wrap="square" lIns="0" tIns="0" rIns="0" bIns="0" rtlCol="0" anchor="ctr"/>
           <a:lstStyle/>
           <a:p>
-            <a:pPr algn="l" indent="0" marL="0">
+            <a:pPr marL="0" indent="0" algn="l">
               <a:buNone/>
             </a:pPr>
             <a:r>
@@ -7864,6 +7966,13 @@
             <a:prstDash val="solid"/>
           </a:ln>
         </p:spPr>
+        <p:txBody>
+          <a:bodyPr/>
+          <a:lstStyle/>
+          <a:p>
+            <a:endParaRPr lang="en-US"/>
+          </a:p>
+        </p:txBody>
       </p:sp>
       <p:sp>
         <p:nvSpPr>
@@ -7886,7 +7995,7 @@
           <a:bodyPr wrap="square" lIns="0" tIns="0" rIns="0" bIns="0" rtlCol="0" anchor="ctr"/>
           <a:lstStyle/>
           <a:p>
-            <a:pPr algn="ctr" indent="0" marL="0">
+            <a:pPr marL="0" indent="0" algn="ctr">
               <a:buNone/>
             </a:pPr>
             <a:r>
@@ -7930,13 +8039,20 @@
             <a:prstDash val="solid"/>
           </a:ln>
           <a:effectLst>
-            <a:outerShdw sx="100000" sy="100000" kx="0" ky="0" algn="bl" rotWithShape="0" blurRad="88900" dist="25400" dir="2700000">
+            <a:outerShdw blurRad="88900" dist="25400" dir="2700000" algn="bl" rotWithShape="0">
               <a:srgbClr val="000000">
                 <a:alpha val="10000"/>
               </a:srgbClr>
             </a:outerShdw>
           </a:effectLst>
         </p:spPr>
+        <p:txBody>
+          <a:bodyPr/>
+          <a:lstStyle/>
+          <a:p>
+            <a:endParaRPr lang="en-US"/>
+          </a:p>
+        </p:txBody>
       </p:sp>
       <p:sp>
         <p:nvSpPr>
@@ -7959,7 +8075,7 @@
           <a:bodyPr wrap="square" lIns="0" tIns="0" rIns="0" bIns="0" rtlCol="0" anchor="ctr"/>
           <a:lstStyle/>
           <a:p>
-            <a:pPr algn="l" indent="0" marL="0">
+            <a:pPr marL="0" indent="0" algn="l">
               <a:buNone/>
             </a:pPr>
             <a:r>
@@ -8001,6 +8117,13 @@
             <a:prstDash val="solid"/>
           </a:ln>
         </p:spPr>
+        <p:txBody>
+          <a:bodyPr/>
+          <a:lstStyle/>
+          <a:p>
+            <a:endParaRPr lang="en-US"/>
+          </a:p>
+        </p:txBody>
       </p:sp>
       <p:sp>
         <p:nvSpPr>
@@ -8023,7 +8146,7 @@
           <a:bodyPr wrap="square" lIns="0" tIns="0" rIns="0" bIns="0" rtlCol="0" anchor="ctr"/>
           <a:lstStyle/>
           <a:p>
-            <a:pPr algn="ctr" indent="0" marL="0">
+            <a:pPr marL="0" indent="0" algn="ctr">
               <a:buNone/>
             </a:pPr>
             <a:r>
@@ -8067,13 +8190,20 @@
             <a:prstDash val="solid"/>
           </a:ln>
           <a:effectLst>
-            <a:outerShdw sx="100000" sy="100000" kx="0" ky="0" algn="bl" rotWithShape="0" blurRad="88900" dist="25400" dir="2700000">
+            <a:outerShdw blurRad="88900" dist="25400" dir="2700000" algn="bl" rotWithShape="0">
               <a:srgbClr val="000000">
                 <a:alpha val="10000"/>
               </a:srgbClr>
             </a:outerShdw>
           </a:effectLst>
         </p:spPr>
+        <p:txBody>
+          <a:bodyPr/>
+          <a:lstStyle/>
+          <a:p>
+            <a:endParaRPr lang="en-US"/>
+          </a:p>
+        </p:txBody>
       </p:sp>
       <p:sp>
         <p:nvSpPr>
@@ -8096,7 +8226,7 @@
           <a:bodyPr wrap="square" lIns="0" tIns="0" rIns="0" bIns="0" rtlCol="0" anchor="ctr"/>
           <a:lstStyle/>
           <a:p>
-            <a:pPr algn="l" indent="0" marL="0">
+            <a:pPr marL="0" indent="0" algn="l">
               <a:buNone/>
             </a:pPr>
             <a:r>
@@ -8130,6 +8260,7 @@
         <a:solidFill>
           <a:srgbClr val="FFFFFF"/>
         </a:solidFill>
+        <a:effectLst/>
       </p:bgPr>
     </p:bg>
     <p:spTree>
@@ -8167,7 +8298,7 @@
           <a:bodyPr wrap="square" lIns="0" tIns="0" rIns="0" bIns="0" rtlCol="0" anchor="ctr"/>
           <a:lstStyle/>
           <a:p>
-            <a:pPr algn="l" indent="0" marL="0">
+            <a:pPr marL="0" indent="0" algn="l">
               <a:buNone/>
             </a:pPr>
             <a:r>
@@ -8211,13 +8342,20 @@
             <a:prstDash val="solid"/>
           </a:ln>
           <a:effectLst>
-            <a:outerShdw sx="100000" sy="100000" kx="0" ky="0" algn="bl" rotWithShape="0" blurRad="88900" dist="25400" dir="2700000">
+            <a:outerShdw blurRad="88900" dist="25400" dir="2700000" algn="bl" rotWithShape="0">
               <a:srgbClr val="000000">
                 <a:alpha val="10000"/>
               </a:srgbClr>
             </a:outerShdw>
           </a:effectLst>
         </p:spPr>
+        <p:txBody>
+          <a:bodyPr/>
+          <a:lstStyle/>
+          <a:p>
+            <a:endParaRPr lang="en-US"/>
+          </a:p>
+        </p:txBody>
       </p:sp>
       <p:sp>
         <p:nvSpPr>
@@ -8240,7 +8378,7 @@
           <a:bodyPr wrap="square" lIns="0" tIns="0" rIns="0" bIns="0" rtlCol="0" anchor="ctr"/>
           <a:lstStyle/>
           <a:p>
-            <a:pPr algn="l" indent="0" marL="0">
+            <a:pPr marL="0" indent="0" algn="l">
               <a:buNone/>
             </a:pPr>
             <a:r>
@@ -8279,7 +8417,7 @@
           <a:bodyPr wrap="square" lIns="0" tIns="0" rIns="0" bIns="0" rtlCol="0" anchor="t"/>
           <a:lstStyle/>
           <a:p>
-            <a:pPr algn="l" marL="342900" indent="-342900">
+            <a:pPr marL="342900" indent="-342900" algn="l">
               <a:buSzPct val="100000"/>
               <a:buChar char="•"/>
             </a:pPr>
@@ -8297,7 +8435,7 @@
             <a:endParaRPr lang="en-US" sz="1150" dirty="0"/>
           </a:p>
           <a:p>
-            <a:pPr algn="l" marL="342900" indent="-342900">
+            <a:pPr marL="342900" indent="-342900" algn="l">
               <a:buSzPct val="100000"/>
               <a:buChar char="•"/>
             </a:pPr>
@@ -8315,7 +8453,7 @@
             <a:endParaRPr lang="en-US" sz="1150" dirty="0"/>
           </a:p>
           <a:p>
-            <a:pPr algn="l" marL="342900" indent="-342900">
+            <a:pPr marL="342900" indent="-342900" algn="l">
               <a:buSzPct val="100000"/>
               <a:buChar char="•"/>
             </a:pPr>
@@ -8360,13 +8498,20 @@
             <a:prstDash val="solid"/>
           </a:ln>
           <a:effectLst>
-            <a:outerShdw sx="100000" sy="100000" kx="0" ky="0" algn="bl" rotWithShape="0" blurRad="88900" dist="25400" dir="2700000">
+            <a:outerShdw blurRad="88900" dist="25400" dir="2700000" algn="bl" rotWithShape="0">
               <a:srgbClr val="000000">
                 <a:alpha val="10000"/>
               </a:srgbClr>
             </a:outerShdw>
           </a:effectLst>
         </p:spPr>
+        <p:txBody>
+          <a:bodyPr/>
+          <a:lstStyle/>
+          <a:p>
+            <a:endParaRPr lang="en-US"/>
+          </a:p>
+        </p:txBody>
       </p:sp>
       <p:sp>
         <p:nvSpPr>
@@ -8389,7 +8534,7 @@
           <a:bodyPr wrap="square" lIns="0" tIns="0" rIns="0" bIns="0" rtlCol="0" anchor="ctr"/>
           <a:lstStyle/>
           <a:p>
-            <a:pPr algn="l" indent="0" marL="0">
+            <a:pPr marL="0" indent="0" algn="l">
               <a:buNone/>
             </a:pPr>
             <a:r>
@@ -8428,7 +8573,7 @@
           <a:bodyPr wrap="square" lIns="0" tIns="0" rIns="0" bIns="0" rtlCol="0" anchor="t"/>
           <a:lstStyle/>
           <a:p>
-            <a:pPr algn="l" marL="342900" indent="-342900">
+            <a:pPr marL="342900" indent="-342900" algn="l">
               <a:buSzPct val="100000"/>
               <a:buChar char="•"/>
             </a:pPr>
@@ -8446,7 +8591,7 @@
             <a:endParaRPr lang="en-US" sz="1150" dirty="0"/>
           </a:p>
           <a:p>
-            <a:pPr algn="l" marL="342900" indent="-342900">
+            <a:pPr marL="342900" indent="-342900" algn="l">
               <a:buSzPct val="100000"/>
               <a:buChar char="•"/>
             </a:pPr>
@@ -8464,7 +8609,7 @@
             <a:endParaRPr lang="en-US" sz="1150" dirty="0"/>
           </a:p>
           <a:p>
-            <a:pPr algn="l" marL="342900" indent="-342900">
+            <a:pPr marL="342900" indent="-342900" algn="l">
               <a:buSzPct val="100000"/>
               <a:buChar char="•"/>
             </a:pPr>
@@ -8509,13 +8654,20 @@
             <a:prstDash val="solid"/>
           </a:ln>
           <a:effectLst>
-            <a:outerShdw sx="100000" sy="100000" kx="0" ky="0" algn="bl" rotWithShape="0" blurRad="88900" dist="25400" dir="2700000">
+            <a:outerShdw blurRad="88900" dist="25400" dir="2700000" algn="bl" rotWithShape="0">
               <a:srgbClr val="000000">
                 <a:alpha val="10000"/>
               </a:srgbClr>
             </a:outerShdw>
           </a:effectLst>
         </p:spPr>
+        <p:txBody>
+          <a:bodyPr/>
+          <a:lstStyle/>
+          <a:p>
+            <a:endParaRPr lang="en-US"/>
+          </a:p>
+        </p:txBody>
       </p:sp>
       <p:sp>
         <p:nvSpPr>
@@ -8538,7 +8690,7 @@
           <a:bodyPr wrap="square" lIns="0" tIns="0" rIns="0" bIns="0" rtlCol="0" anchor="ctr"/>
           <a:lstStyle/>
           <a:p>
-            <a:pPr algn="l" indent="0" marL="0">
+            <a:pPr marL="0" indent="0" algn="l">
               <a:buNone/>
             </a:pPr>
             <a:r>
@@ -8577,7 +8729,7 @@
           <a:bodyPr wrap="square" lIns="0" tIns="0" rIns="0" bIns="0" rtlCol="0" anchor="t"/>
           <a:lstStyle/>
           <a:p>
-            <a:pPr algn="l" marL="342900" indent="-342900">
+            <a:pPr marL="342900" indent="-342900" algn="l">
               <a:buSzPct val="100000"/>
               <a:buChar char="•"/>
             </a:pPr>
@@ -8595,7 +8747,7 @@
             <a:endParaRPr lang="en-US" sz="1150" dirty="0"/>
           </a:p>
           <a:p>
-            <a:pPr algn="l" marL="342900" indent="-342900">
+            <a:pPr marL="342900" indent="-342900" algn="l">
               <a:buSzPct val="100000"/>
               <a:buChar char="•"/>
             </a:pPr>
@@ -8640,13 +8792,20 @@
             <a:prstDash val="solid"/>
           </a:ln>
           <a:effectLst>
-            <a:outerShdw sx="100000" sy="100000" kx="0" ky="0" algn="bl" rotWithShape="0" blurRad="88900" dist="25400" dir="2700000">
+            <a:outerShdw blurRad="88900" dist="25400" dir="2700000" algn="bl" rotWithShape="0">
               <a:srgbClr val="000000">
                 <a:alpha val="10000"/>
               </a:srgbClr>
             </a:outerShdw>
           </a:effectLst>
         </p:spPr>
+        <p:txBody>
+          <a:bodyPr/>
+          <a:lstStyle/>
+          <a:p>
+            <a:endParaRPr lang="en-US"/>
+          </a:p>
+        </p:txBody>
       </p:sp>
       <p:sp>
         <p:nvSpPr>
@@ -8669,7 +8828,7 @@
           <a:bodyPr wrap="square" lIns="0" tIns="0" rIns="0" bIns="0" rtlCol="0" anchor="ctr"/>
           <a:lstStyle/>
           <a:p>
-            <a:pPr algn="l" indent="0" marL="0">
+            <a:pPr marL="0" indent="0" algn="l">
               <a:buNone/>
             </a:pPr>
             <a:r>
@@ -8708,7 +8867,7 @@
           <a:bodyPr wrap="square" lIns="0" tIns="0" rIns="0" bIns="0" rtlCol="0" anchor="t"/>
           <a:lstStyle/>
           <a:p>
-            <a:pPr algn="l" marL="342900" indent="-342900">
+            <a:pPr marL="342900" indent="-342900" algn="l">
               <a:buSzPct val="100000"/>
               <a:buChar char="•"/>
             </a:pPr>
@@ -8726,7 +8885,7 @@
             <a:endParaRPr lang="en-US" sz="1150" dirty="0"/>
           </a:p>
           <a:p>
-            <a:pPr algn="l" marL="342900" indent="-342900">
+            <a:pPr marL="342900" indent="-342900" algn="l">
               <a:buSzPct val="100000"/>
               <a:buChar char="•"/>
             </a:pPr>
@@ -8744,7 +8903,7 @@
             <a:endParaRPr lang="en-US" sz="1150" dirty="0"/>
           </a:p>
           <a:p>
-            <a:pPr algn="l" marL="342900" indent="-342900">
+            <a:pPr marL="342900" indent="-342900" algn="l">
               <a:buSzPct val="100000"/>
               <a:buChar char="•"/>
             </a:pPr>
@@ -8779,6 +8938,7 @@
         <a:solidFill>
           <a:srgbClr val="FFFFFF"/>
         </a:solidFill>
+        <a:effectLst/>
       </p:bgPr>
     </p:bg>
     <p:spTree>
@@ -8816,7 +8976,7 @@
           <a:bodyPr wrap="square" lIns="0" tIns="0" rIns="0" bIns="0" rtlCol="0" anchor="ctr"/>
           <a:lstStyle/>
           <a:p>
-            <a:pPr algn="l" indent="0" marL="0">
+            <a:pPr marL="0" indent="0" algn="l">
               <a:buNone/>
             </a:pPr>
             <a:r>
@@ -8860,17 +9020,24 @@
             <a:prstDash val="dash"/>
           </a:ln>
         </p:spPr>
-      </p:sp>
-      <p:sp>
-        <p:nvSpPr>
-          <p:cNvPr id="4" name="Text 2"/>
-          <p:cNvSpPr/>
-          <p:nvPr/>
-        </p:nvSpPr>
-        <p:spPr>
-          <a:xfrm>
-            <a:off x="594360" y="2011680"/>
-            <a:ext cx="7955280" cy="640080"/>
+        <p:txBody>
+          <a:bodyPr/>
+          <a:lstStyle/>
+          <a:p>
+            <a:endParaRPr lang="en-US"/>
+          </a:p>
+        </p:txBody>
+      </p:sp>
+      <p:sp>
+        <p:nvSpPr>
+          <p:cNvPr id="5" name="Text 3"/>
+          <p:cNvSpPr/>
+          <p:nvPr/>
+        </p:nvSpPr>
+        <p:spPr>
+          <a:xfrm>
+            <a:off x="594360" y="2788920"/>
+            <a:ext cx="7955280" cy="411480"/>
           </a:xfrm>
           <a:prstGeom prst="rect">
             <a:avLst/>
@@ -8882,46 +9049,7 @@
           <a:bodyPr wrap="square" lIns="0" tIns="0" rIns="0" bIns="0" rtlCol="0" anchor="ctr"/>
           <a:lstStyle/>
           <a:p>
-            <a:pPr algn="ctr" indent="0" marL="0">
-              <a:buNone/>
-            </a:pPr>
-            <a:r>
-              <a:rPr lang="en-US" sz="2400" i="1" dirty="0">
-                <a:solidFill>
-                  <a:srgbClr val="C4B9AC"/>
-                </a:solidFill>
-                <a:latin typeface="Cambria" pitchFamily="34" charset="0"/>
-                <a:ea typeface="Cambria" pitchFamily="34" charset="-122"/>
-                <a:cs typeface="Cambria" pitchFamily="34" charset="-120"/>
-              </a:rPr>
-              <a:t>[ ERD Diagram ]</a:t>
-            </a:r>
-            <a:endParaRPr lang="en-US" sz="2400" dirty="0"/>
-          </a:p>
-        </p:txBody>
-      </p:sp>
-      <p:sp>
-        <p:nvSpPr>
-          <p:cNvPr id="5" name="Text 3"/>
-          <p:cNvSpPr/>
-          <p:nvPr/>
-        </p:nvSpPr>
-        <p:spPr>
-          <a:xfrm>
-            <a:off x="594360" y="2788920"/>
-            <a:ext cx="7955280" cy="411480"/>
-          </a:xfrm>
-          <a:prstGeom prst="rect">
-            <a:avLst/>
-          </a:prstGeom>
-          <a:noFill/>
-          <a:ln/>
-        </p:spPr>
-        <p:txBody>
-          <a:bodyPr wrap="square" lIns="0" tIns="0" rIns="0" bIns="0" rtlCol="0" anchor="ctr"/>
-          <a:lstStyle/>
-          <a:p>
-            <a:pPr algn="ctr" indent="0" marL="0">
+            <a:pPr marL="0" indent="0" algn="ctr">
               <a:buNone/>
             </a:pPr>
             <a:r>
@@ -8960,7 +9088,7 @@
           <a:bodyPr wrap="square" lIns="0" tIns="0" rIns="0" bIns="0" rtlCol="0" anchor="ctr"/>
           <a:lstStyle/>
           <a:p>
-            <a:pPr algn="ctr" indent="0" marL="0">
+            <a:pPr marL="0" indent="0" algn="ctr">
               <a:buNone/>
             </a:pPr>
             <a:r>
@@ -8978,6 +9106,36 @@
           </a:p>
         </p:txBody>
       </p:sp>
+      <p:pic>
+        <p:nvPicPr>
+          <p:cNvPr id="8" name="Picture 7">
+            <a:extLst>
+              <a:ext uri="{FF2B5EF4-FFF2-40B4-BE49-F238E27FC236}">
+                <a16:creationId xmlns:a16="http://schemas.microsoft.com/office/drawing/2014/main" id="{82151C20-B282-12D1-EE61-693AE0184A16}"/>
+              </a:ext>
+            </a:extLst>
+          </p:cNvPr>
+          <p:cNvPicPr>
+            <a:picLocks noChangeAspect="1"/>
+          </p:cNvPicPr>
+          <p:nvPr/>
+        </p:nvPicPr>
+        <p:blipFill>
+          <a:blip r:embed="rId3"/>
+          <a:stretch>
+            <a:fillRect/>
+          </a:stretch>
+        </p:blipFill>
+        <p:spPr>
+          <a:xfrm>
+            <a:off x="1491521" y="914400"/>
+            <a:ext cx="5891136" cy="3931920"/>
+          </a:xfrm>
+          <a:prstGeom prst="rect">
+            <a:avLst/>
+          </a:prstGeom>
+        </p:spPr>
+      </p:pic>
     </p:spTree>
   </p:cSld>
   <p:clrMapOvr>
@@ -8994,6 +9152,7 @@
         <a:solidFill>
           <a:srgbClr val="FFFFFF"/>
         </a:solidFill>
+        <a:effectLst/>
       </p:bgPr>
     </p:bg>
     <p:spTree>
@@ -9031,7 +9190,7 @@
           <a:bodyPr wrap="square" lIns="0" tIns="0" rIns="0" bIns="0" rtlCol="0" anchor="ctr"/>
           <a:lstStyle/>
           <a:p>
-            <a:pPr algn="l" indent="0" marL="0">
+            <a:pPr marL="0" indent="0" algn="l">
               <a:buNone/>
             </a:pPr>
             <a:r>
@@ -9075,13 +9234,20 @@
             <a:prstDash val="solid"/>
           </a:ln>
           <a:effectLst>
-            <a:outerShdw sx="100000" sy="100000" kx="0" ky="0" algn="bl" rotWithShape="0" blurRad="88900" dist="25400" dir="2700000">
+            <a:outerShdw blurRad="88900" dist="25400" dir="2700000" algn="bl" rotWithShape="0">
               <a:srgbClr val="000000">
                 <a:alpha val="10000"/>
               </a:srgbClr>
             </a:outerShdw>
           </a:effectLst>
         </p:spPr>
+        <p:txBody>
+          <a:bodyPr/>
+          <a:lstStyle/>
+          <a:p>
+            <a:endParaRPr lang="en-US"/>
+          </a:p>
+        </p:txBody>
       </p:sp>
       <p:sp>
         <p:nvSpPr>
@@ -9107,6 +9273,13 @@
             <a:prstDash val="solid"/>
           </a:ln>
         </p:spPr>
+        <p:txBody>
+          <a:bodyPr/>
+          <a:lstStyle/>
+          <a:p>
+            <a:endParaRPr lang="en-US"/>
+          </a:p>
+        </p:txBody>
       </p:sp>
       <p:sp>
         <p:nvSpPr>
@@ -9129,7 +9302,7 @@
           <a:bodyPr wrap="square" lIns="0" tIns="0" rIns="0" bIns="0" rtlCol="0" anchor="ctr"/>
           <a:lstStyle/>
           <a:p>
-            <a:pPr algn="ctr" indent="0" marL="0">
+            <a:pPr marL="0" indent="0" algn="ctr">
               <a:buNone/>
             </a:pPr>
             <a:r>
@@ -9168,7 +9341,7 @@
           <a:bodyPr wrap="square" lIns="0" tIns="0" rIns="0" bIns="0" rtlCol="0" anchor="ctr"/>
           <a:lstStyle/>
           <a:p>
-            <a:pPr algn="l" indent="0" marL="0">
+            <a:pPr marL="0" indent="0" algn="l">
               <a:buNone/>
             </a:pPr>
             <a:r>
@@ -9207,7 +9380,7 @@
           <a:bodyPr wrap="square" lIns="0" tIns="0" rIns="0" bIns="0" rtlCol="0" anchor="t"/>
           <a:lstStyle/>
           <a:p>
-            <a:pPr algn="l" indent="0" marL="0">
+            <a:pPr marL="0" indent="0" algn="l">
               <a:buNone/>
             </a:pPr>
             <a:r>
@@ -9251,13 +9424,20 @@
             <a:prstDash val="solid"/>
           </a:ln>
           <a:effectLst>
-            <a:outerShdw sx="100000" sy="100000" kx="0" ky="0" algn="bl" rotWithShape="0" blurRad="88900" dist="25400" dir="2700000">
+            <a:outerShdw blurRad="88900" dist="25400" dir="2700000" algn="bl" rotWithShape="0">
               <a:srgbClr val="000000">
                 <a:alpha val="10000"/>
               </a:srgbClr>
             </a:outerShdw>
           </a:effectLst>
         </p:spPr>
+        <p:txBody>
+          <a:bodyPr/>
+          <a:lstStyle/>
+          <a:p>
+            <a:endParaRPr lang="en-US"/>
+          </a:p>
+        </p:txBody>
       </p:sp>
       <p:sp>
         <p:nvSpPr>
@@ -9283,6 +9463,13 @@
             <a:prstDash val="solid"/>
           </a:ln>
         </p:spPr>
+        <p:txBody>
+          <a:bodyPr/>
+          <a:lstStyle/>
+          <a:p>
+            <a:endParaRPr lang="en-US"/>
+          </a:p>
+        </p:txBody>
       </p:sp>
       <p:sp>
         <p:nvSpPr>
@@ -9305,7 +9492,7 @@
           <a:bodyPr wrap="square" lIns="0" tIns="0" rIns="0" bIns="0" rtlCol="0" anchor="ctr"/>
           <a:lstStyle/>
           <a:p>
-            <a:pPr algn="ctr" indent="0" marL="0">
+            <a:pPr marL="0" indent="0" algn="ctr">
               <a:buNone/>
             </a:pPr>
             <a:r>
@@ -9344,7 +9531,7 @@
           <a:bodyPr wrap="square" lIns="0" tIns="0" rIns="0" bIns="0" rtlCol="0" anchor="ctr"/>
           <a:lstStyle/>
           <a:p>
-            <a:pPr algn="l" indent="0" marL="0">
+            <a:pPr marL="0" indent="0" algn="l">
               <a:buNone/>
             </a:pPr>
             <a:r>
@@ -9383,7 +9570,7 @@
           <a:bodyPr wrap="square" lIns="0" tIns="0" rIns="0" bIns="0" rtlCol="0" anchor="t"/>
           <a:lstStyle/>
           <a:p>
-            <a:pPr algn="l" indent="0" marL="0">
+            <a:pPr marL="0" indent="0" algn="l">
               <a:buNone/>
             </a:pPr>
             <a:r>
@@ -9427,13 +9614,20 @@
             <a:prstDash val="solid"/>
           </a:ln>
           <a:effectLst>
-            <a:outerShdw sx="100000" sy="100000" kx="0" ky="0" algn="bl" rotWithShape="0" blurRad="88900" dist="25400" dir="2700000">
+            <a:outerShdw blurRad="88900" dist="25400" dir="2700000" algn="bl" rotWithShape="0">
               <a:srgbClr val="000000">
                 <a:alpha val="10000"/>
               </a:srgbClr>
             </a:outerShdw>
           </a:effectLst>
         </p:spPr>
+        <p:txBody>
+          <a:bodyPr/>
+          <a:lstStyle/>
+          <a:p>
+            <a:endParaRPr lang="en-US"/>
+          </a:p>
+        </p:txBody>
       </p:sp>
       <p:sp>
         <p:nvSpPr>
@@ -9459,6 +9653,13 @@
             <a:prstDash val="solid"/>
           </a:ln>
         </p:spPr>
+        <p:txBody>
+          <a:bodyPr/>
+          <a:lstStyle/>
+          <a:p>
+            <a:endParaRPr lang="en-US"/>
+          </a:p>
+        </p:txBody>
       </p:sp>
       <p:sp>
         <p:nvSpPr>
@@ -9481,7 +9682,7 @@
           <a:bodyPr wrap="square" lIns="0" tIns="0" rIns="0" bIns="0" rtlCol="0" anchor="ctr"/>
           <a:lstStyle/>
           <a:p>
-            <a:pPr algn="ctr" indent="0" marL="0">
+            <a:pPr marL="0" indent="0" algn="ctr">
               <a:buNone/>
             </a:pPr>
             <a:r>
@@ -9520,7 +9721,7 @@
           <a:bodyPr wrap="square" lIns="0" tIns="0" rIns="0" bIns="0" rtlCol="0" anchor="ctr"/>
           <a:lstStyle/>
           <a:p>
-            <a:pPr algn="l" indent="0" marL="0">
+            <a:pPr marL="0" indent="0" algn="l">
               <a:buNone/>
             </a:pPr>
             <a:r>
@@ -9559,7 +9760,7 @@
           <a:bodyPr wrap="square" lIns="0" tIns="0" rIns="0" bIns="0" rtlCol="0" anchor="t"/>
           <a:lstStyle/>
           <a:p>
-            <a:pPr algn="l" indent="0" marL="0">
+            <a:pPr marL="0" indent="0" algn="l">
               <a:buNone/>
             </a:pPr>
             <a:r>
@@ -9603,13 +9804,20 @@
             <a:prstDash val="solid"/>
           </a:ln>
           <a:effectLst>
-            <a:outerShdw sx="100000" sy="100000" kx="0" ky="0" algn="bl" rotWithShape="0" blurRad="88900" dist="25400" dir="2700000">
+            <a:outerShdw blurRad="88900" dist="25400" dir="2700000" algn="bl" rotWithShape="0">
               <a:srgbClr val="000000">
                 <a:alpha val="10000"/>
               </a:srgbClr>
             </a:outerShdw>
           </a:effectLst>
         </p:spPr>
+        <p:txBody>
+          <a:bodyPr/>
+          <a:lstStyle/>
+          <a:p>
+            <a:endParaRPr lang="en-US"/>
+          </a:p>
+        </p:txBody>
       </p:sp>
       <p:sp>
         <p:nvSpPr>
@@ -9635,6 +9843,13 @@
             <a:prstDash val="solid"/>
           </a:ln>
         </p:spPr>
+        <p:txBody>
+          <a:bodyPr/>
+          <a:lstStyle/>
+          <a:p>
+            <a:endParaRPr lang="en-US"/>
+          </a:p>
+        </p:txBody>
       </p:sp>
       <p:sp>
         <p:nvSpPr>
@@ -9657,7 +9872,7 @@
           <a:bodyPr wrap="square" lIns="0" tIns="0" rIns="0" bIns="0" rtlCol="0" anchor="ctr"/>
           <a:lstStyle/>
           <a:p>
-            <a:pPr algn="ctr" indent="0" marL="0">
+            <a:pPr marL="0" indent="0" algn="ctr">
               <a:buNone/>
             </a:pPr>
             <a:r>
@@ -9696,7 +9911,7 @@
           <a:bodyPr wrap="square" lIns="0" tIns="0" rIns="0" bIns="0" rtlCol="0" anchor="ctr"/>
           <a:lstStyle/>
           <a:p>
-            <a:pPr algn="l" indent="0" marL="0">
+            <a:pPr marL="0" indent="0" algn="l">
               <a:buNone/>
             </a:pPr>
             <a:r>
@@ -9735,7 +9950,7 @@
           <a:bodyPr wrap="square" lIns="0" tIns="0" rIns="0" bIns="0" rtlCol="0" anchor="t"/>
           <a:lstStyle/>
           <a:p>
-            <a:pPr algn="l" indent="0" marL="0">
+            <a:pPr marL="0" indent="0" algn="l">
               <a:buNone/>
             </a:pPr>
             <a:r>
@@ -9779,13 +9994,20 @@
             <a:prstDash val="solid"/>
           </a:ln>
           <a:effectLst>
-            <a:outerShdw sx="100000" sy="100000" kx="0" ky="0" algn="bl" rotWithShape="0" blurRad="88900" dist="25400" dir="2700000">
+            <a:outerShdw blurRad="88900" dist="25400" dir="2700000" algn="bl" rotWithShape="0">
               <a:srgbClr val="000000">
                 <a:alpha val="10000"/>
               </a:srgbClr>
             </a:outerShdw>
           </a:effectLst>
         </p:spPr>
+        <p:txBody>
+          <a:bodyPr/>
+          <a:lstStyle/>
+          <a:p>
+            <a:endParaRPr lang="en-US"/>
+          </a:p>
+        </p:txBody>
       </p:sp>
       <p:sp>
         <p:nvSpPr>
@@ -9811,6 +10033,13 @@
             <a:prstDash val="solid"/>
           </a:ln>
         </p:spPr>
+        <p:txBody>
+          <a:bodyPr/>
+          <a:lstStyle/>
+          <a:p>
+            <a:endParaRPr lang="en-US"/>
+          </a:p>
+        </p:txBody>
       </p:sp>
       <p:sp>
         <p:nvSpPr>
@@ -9833,7 +10062,7 @@
           <a:bodyPr wrap="square" lIns="0" tIns="0" rIns="0" bIns="0" rtlCol="0" anchor="ctr"/>
           <a:lstStyle/>
           <a:p>
-            <a:pPr algn="ctr" indent="0" marL="0">
+            <a:pPr marL="0" indent="0" algn="ctr">
               <a:buNone/>
             </a:pPr>
             <a:r>
@@ -9872,7 +10101,7 @@
           <a:bodyPr wrap="square" lIns="0" tIns="0" rIns="0" bIns="0" rtlCol="0" anchor="ctr"/>
           <a:lstStyle/>
           <a:p>
-            <a:pPr algn="l" indent="0" marL="0">
+            <a:pPr marL="0" indent="0" algn="l">
               <a:buNone/>
             </a:pPr>
             <a:r>
@@ -9911,7 +10140,7 @@
           <a:bodyPr wrap="square" lIns="0" tIns="0" rIns="0" bIns="0" rtlCol="0" anchor="t"/>
           <a:lstStyle/>
           <a:p>
-            <a:pPr algn="l" indent="0" marL="0">
+            <a:pPr marL="0" indent="0" algn="l">
               <a:buNone/>
             </a:pPr>
             <a:r>
@@ -9955,13 +10184,20 @@
             <a:prstDash val="solid"/>
           </a:ln>
           <a:effectLst>
-            <a:outerShdw sx="100000" sy="100000" kx="0" ky="0" algn="bl" rotWithShape="0" blurRad="88900" dist="25400" dir="2700000">
+            <a:outerShdw blurRad="88900" dist="25400" dir="2700000" algn="bl" rotWithShape="0">
               <a:srgbClr val="000000">
                 <a:alpha val="10000"/>
               </a:srgbClr>
             </a:outerShdw>
           </a:effectLst>
         </p:spPr>
+        <p:txBody>
+          <a:bodyPr/>
+          <a:lstStyle/>
+          <a:p>
+            <a:endParaRPr lang="en-US"/>
+          </a:p>
+        </p:txBody>
       </p:sp>
       <p:sp>
         <p:nvSpPr>
@@ -9987,6 +10223,13 @@
             <a:prstDash val="solid"/>
           </a:ln>
         </p:spPr>
+        <p:txBody>
+          <a:bodyPr/>
+          <a:lstStyle/>
+          <a:p>
+            <a:endParaRPr lang="en-US"/>
+          </a:p>
+        </p:txBody>
       </p:sp>
       <p:sp>
         <p:nvSpPr>
@@ -10009,7 +10252,7 @@
           <a:bodyPr wrap="square" lIns="0" tIns="0" rIns="0" bIns="0" rtlCol="0" anchor="ctr"/>
           <a:lstStyle/>
           <a:p>
-            <a:pPr algn="ctr" indent="0" marL="0">
+            <a:pPr marL="0" indent="0" algn="ctr">
               <a:buNone/>
             </a:pPr>
             <a:r>
@@ -10048,7 +10291,7 @@
           <a:bodyPr wrap="square" lIns="0" tIns="0" rIns="0" bIns="0" rtlCol="0" anchor="ctr"/>
           <a:lstStyle/>
           <a:p>
-            <a:pPr algn="l" indent="0" marL="0">
+            <a:pPr marL="0" indent="0" algn="l">
               <a:buNone/>
             </a:pPr>
             <a:r>
@@ -10087,7 +10330,7 @@
           <a:bodyPr wrap="square" lIns="0" tIns="0" rIns="0" bIns="0" rtlCol="0" anchor="t"/>
           <a:lstStyle/>
           <a:p>
-            <a:pPr algn="l" indent="0" marL="0">
+            <a:pPr marL="0" indent="0" algn="l">
               <a:buNone/>
             </a:pPr>
             <a:r>
@@ -10126,7 +10369,7 @@
           <a:bodyPr wrap="square" lIns="0" tIns="0" rIns="0" bIns="0" rtlCol="0" anchor="ctr"/>
           <a:lstStyle/>
           <a:p>
-            <a:pPr algn="ctr" indent="0" marL="0">
+            <a:pPr marL="0" indent="0" algn="ctr">
               <a:buNone/>
             </a:pPr>
             <a:r>
@@ -10445,4 +10688,319 @@
     </a:ext>
   </a:extLst>
 </a:theme>
+</file>
+
+<file path=ppt/theme/theme2.xml><?xml version="1.0" encoding="utf-8"?>
+<a:theme xmlns:a="http://schemas.openxmlformats.org/drawingml/2006/main" name="Office Theme">
+  <a:themeElements>
+    <a:clrScheme name="Office">
+      <a:dk1>
+        <a:sysClr val="windowText" lastClr="000000"/>
+      </a:dk1>
+      <a:lt1>
+        <a:sysClr val="window" lastClr="FFFFFF"/>
+      </a:lt1>
+      <a:dk2>
+        <a:srgbClr val="0E2841"/>
+      </a:dk2>
+      <a:lt2>
+        <a:srgbClr val="E8E8E8"/>
+      </a:lt2>
+      <a:accent1>
+        <a:srgbClr val="156082"/>
+      </a:accent1>
+      <a:accent2>
+        <a:srgbClr val="E97132"/>
+      </a:accent2>
+      <a:accent3>
+        <a:srgbClr val="196B24"/>
+      </a:accent3>
+      <a:accent4>
+        <a:srgbClr val="0F9ED5"/>
+      </a:accent4>
+      <a:accent5>
+        <a:srgbClr val="A02B93"/>
+      </a:accent5>
+      <a:accent6>
+        <a:srgbClr val="4EA72E"/>
+      </a:accent6>
+      <a:hlink>
+        <a:srgbClr val="467886"/>
+      </a:hlink>
+      <a:folHlink>
+        <a:srgbClr val="96607D"/>
+      </a:folHlink>
+    </a:clrScheme>
+    <a:fontScheme name="Office">
+      <a:majorFont>
+        <a:latin typeface="Aptos Display" panose="02110004020202020204"/>
+        <a:ea typeface=""/>
+        <a:cs typeface=""/>
+        <a:font script="Jpan" typeface="游ゴシック Light"/>
+        <a:font script="Hang" typeface="맑은 고딕"/>
+        <a:font script="Hans" typeface="等线 Light"/>
+        <a:font script="Hant" typeface="新細明體"/>
+        <a:font script="Arab" typeface="Times New Roman"/>
+        <a:font script="Hebr" typeface="Times New Roman"/>
+        <a:font script="Thai" typeface="Angsana New"/>
+        <a:font script="Ethi" typeface="Nyala"/>
+        <a:font script="Beng" typeface="Vrinda"/>
+        <a:font script="Gujr" typeface="Shruti"/>
+        <a:font script="Khmr" typeface="MoolBoran"/>
+        <a:font script="Knda" typeface="Tunga"/>
+        <a:font script="Guru" typeface="Raavi"/>
+        <a:font script="Cans" typeface="Euphemia"/>
+        <a:font script="Cher" typeface="Plantagenet Cherokee"/>
+        <a:font script="Yiii" typeface="Microsoft Yi Baiti"/>
+        <a:font script="Tibt" typeface="Microsoft Himalaya"/>
+        <a:font script="Thaa" typeface="MV Boli"/>
+        <a:font script="Deva" typeface="Mangal"/>
+        <a:font script="Telu" typeface="Gautami"/>
+        <a:font script="Taml" typeface="Latha"/>
+        <a:font script="Syrc" typeface="Estrangelo Edessa"/>
+        <a:font script="Orya" typeface="Kalinga"/>
+        <a:font script="Mlym" typeface="Kartika"/>
+        <a:font script="Laoo" typeface="DokChampa"/>
+        <a:font script="Sinh" typeface="Iskoola Pota"/>
+        <a:font script="Mong" typeface="Mongolian Baiti"/>
+        <a:font script="Viet" typeface="Times New Roman"/>
+        <a:font script="Uigh" typeface="Microsoft Uighur"/>
+        <a:font script="Geor" typeface="Sylfaen"/>
+        <a:font script="Armn" typeface="Arial"/>
+        <a:font script="Bugi" typeface="Leelawadee UI"/>
+        <a:font script="Bopo" typeface="Microsoft JhengHei"/>
+        <a:font script="Java" typeface="Javanese Text"/>
+        <a:font script="Lisu" typeface="Segoe UI"/>
+        <a:font script="Mymr" typeface="Myanmar Text"/>
+        <a:font script="Nkoo" typeface="Ebrima"/>
+        <a:font script="Olck" typeface="Nirmala UI"/>
+        <a:font script="Osma" typeface="Ebrima"/>
+        <a:font script="Phag" typeface="Phagspa"/>
+        <a:font script="Syrn" typeface="Estrangelo Edessa"/>
+        <a:font script="Syrj" typeface="Estrangelo Edessa"/>
+        <a:font script="Syre" typeface="Estrangelo Edessa"/>
+        <a:font script="Sora" typeface="Nirmala UI"/>
+        <a:font script="Tale" typeface="Microsoft Tai Le"/>
+        <a:font script="Talu" typeface="Microsoft New Tai Lue"/>
+        <a:font script="Tfng" typeface="Ebrima"/>
+      </a:majorFont>
+      <a:minorFont>
+        <a:latin typeface="Aptos" panose="02110004020202020204"/>
+        <a:ea typeface=""/>
+        <a:cs typeface=""/>
+        <a:font script="Jpan" typeface="游ゴシック"/>
+        <a:font script="Hang" typeface="맑은 고딕"/>
+        <a:font script="Hans" typeface="等线"/>
+        <a:font script="Hant" typeface="新細明體"/>
+        <a:font script="Arab" typeface="Arial"/>
+        <a:font script="Hebr" typeface="Arial"/>
+        <a:font script="Thai" typeface="Cordia New"/>
+        <a:font script="Ethi" typeface="Nyala"/>
+        <a:font script="Beng" typeface="Vrinda"/>
+        <a:font script="Gujr" typeface="Shruti"/>
+        <a:font script="Khmr" typeface="DaunPenh"/>
+        <a:font script="Knda" typeface="Tunga"/>
+        <a:font script="Guru" typeface="Raavi"/>
+        <a:font script="Cans" typeface="Euphemia"/>
+        <a:font script="Cher" typeface="Plantagenet Cherokee"/>
+        <a:font script="Yiii" typeface="Microsoft Yi Baiti"/>
+        <a:font script="Tibt" typeface="Microsoft Himalaya"/>
+        <a:font script="Thaa" typeface="MV Boli"/>
+        <a:font script="Deva" typeface="Mangal"/>
+        <a:font script="Telu" typeface="Gautami"/>
+        <a:font script="Taml" typeface="Latha"/>
+        <a:font script="Syrc" typeface="Estrangelo Edessa"/>
+        <a:font script="Orya" typeface="Kalinga"/>
+        <a:font script="Mlym" typeface="Kartika"/>
+        <a:font script="Laoo" typeface="DokChampa"/>
+        <a:font script="Sinh" typeface="Iskoola Pota"/>
+        <a:font script="Mong" typeface="Mongolian Baiti"/>
+        <a:font script="Viet" typeface="Arial"/>
+        <a:font script="Uigh" typeface="Microsoft Uighur"/>
+        <a:font script="Geor" typeface="Sylfaen"/>
+        <a:font script="Armn" typeface="Arial"/>
+        <a:font script="Bugi" typeface="Leelawadee UI"/>
+        <a:font script="Bopo" typeface="Microsoft JhengHei"/>
+        <a:font script="Java" typeface="Javanese Text"/>
+        <a:font script="Lisu" typeface="Segoe UI"/>
+        <a:font script="Mymr" typeface="Myanmar Text"/>
+        <a:font script="Nkoo" typeface="Ebrima"/>
+        <a:font script="Olck" typeface="Nirmala UI"/>
+        <a:font script="Osma" typeface="Ebrima"/>
+        <a:font script="Phag" typeface="Phagspa"/>
+        <a:font script="Syrn" typeface="Estrangelo Edessa"/>
+        <a:font script="Syrj" typeface="Estrangelo Edessa"/>
+        <a:font script="Syre" typeface="Estrangelo Edessa"/>
+        <a:font script="Sora" typeface="Nirmala UI"/>
+        <a:font script="Tale" typeface="Microsoft Tai Le"/>
+        <a:font script="Talu" typeface="Microsoft New Tai Lue"/>
+        <a:font script="Tfng" typeface="Ebrima"/>
+      </a:minorFont>
+    </a:fontScheme>
+    <a:fmtScheme name="Office">
+      <a:fillStyleLst>
+        <a:solidFill>
+          <a:schemeClr val="phClr"/>
+        </a:solidFill>
+        <a:gradFill rotWithShape="1">
+          <a:gsLst>
+            <a:gs pos="0">
+              <a:schemeClr val="phClr">
+                <a:lumMod val="110000"/>
+                <a:satMod val="105000"/>
+                <a:tint val="67000"/>
+              </a:schemeClr>
+            </a:gs>
+            <a:gs pos="50000">
+              <a:schemeClr val="phClr">
+                <a:lumMod val="105000"/>
+                <a:satMod val="103000"/>
+                <a:tint val="73000"/>
+              </a:schemeClr>
+            </a:gs>
+            <a:gs pos="100000">
+              <a:schemeClr val="phClr">
+                <a:lumMod val="105000"/>
+                <a:satMod val="109000"/>
+                <a:tint val="81000"/>
+              </a:schemeClr>
+            </a:gs>
+          </a:gsLst>
+          <a:lin ang="5400000" scaled="0"/>
+        </a:gradFill>
+        <a:gradFill rotWithShape="1">
+          <a:gsLst>
+            <a:gs pos="0">
+              <a:schemeClr val="phClr">
+                <a:satMod val="103000"/>
+                <a:lumMod val="102000"/>
+                <a:tint val="94000"/>
+              </a:schemeClr>
+            </a:gs>
+            <a:gs pos="50000">
+              <a:schemeClr val="phClr">
+                <a:satMod val="110000"/>
+                <a:lumMod val="100000"/>
+                <a:shade val="100000"/>
+              </a:schemeClr>
+            </a:gs>
+            <a:gs pos="100000">
+              <a:schemeClr val="phClr">
+                <a:lumMod val="99000"/>
+                <a:satMod val="120000"/>
+                <a:shade val="78000"/>
+              </a:schemeClr>
+            </a:gs>
+          </a:gsLst>
+          <a:lin ang="5400000" scaled="0"/>
+        </a:gradFill>
+      </a:fillStyleLst>
+      <a:lnStyleLst>
+        <a:ln w="12700" cap="flat" cmpd="sng" algn="ctr">
+          <a:solidFill>
+            <a:schemeClr val="phClr"/>
+          </a:solidFill>
+          <a:prstDash val="solid"/>
+          <a:miter lim="800000"/>
+        </a:ln>
+        <a:ln w="19050" cap="flat" cmpd="sng" algn="ctr">
+          <a:solidFill>
+            <a:schemeClr val="phClr"/>
+          </a:solidFill>
+          <a:prstDash val="solid"/>
+          <a:miter lim="800000"/>
+        </a:ln>
+        <a:ln w="25400" cap="flat" cmpd="sng" algn="ctr">
+          <a:solidFill>
+            <a:schemeClr val="phClr"/>
+          </a:solidFill>
+          <a:prstDash val="solid"/>
+          <a:miter lim="800000"/>
+        </a:ln>
+      </a:lnStyleLst>
+      <a:effectStyleLst>
+        <a:effectStyle>
+          <a:effectLst/>
+        </a:effectStyle>
+        <a:effectStyle>
+          <a:effectLst/>
+        </a:effectStyle>
+        <a:effectStyle>
+          <a:effectLst>
+            <a:outerShdw blurRad="57150" dist="19050" dir="5400000" algn="ctr" rotWithShape="0">
+              <a:srgbClr val="000000">
+                <a:alpha val="63000"/>
+              </a:srgbClr>
+            </a:outerShdw>
+          </a:effectLst>
+        </a:effectStyle>
+      </a:effectStyleLst>
+      <a:bgFillStyleLst>
+        <a:solidFill>
+          <a:schemeClr val="phClr"/>
+        </a:solidFill>
+        <a:solidFill>
+          <a:schemeClr val="phClr">
+            <a:tint val="95000"/>
+            <a:satMod val="170000"/>
+          </a:schemeClr>
+        </a:solidFill>
+        <a:gradFill rotWithShape="1">
+          <a:gsLst>
+            <a:gs pos="0">
+              <a:schemeClr val="phClr">
+                <a:tint val="93000"/>
+                <a:satMod val="150000"/>
+                <a:shade val="98000"/>
+                <a:lumMod val="102000"/>
+              </a:schemeClr>
+            </a:gs>
+            <a:gs pos="50000">
+              <a:schemeClr val="phClr">
+                <a:tint val="98000"/>
+                <a:satMod val="130000"/>
+                <a:shade val="90000"/>
+                <a:lumMod val="103000"/>
+              </a:schemeClr>
+            </a:gs>
+            <a:gs pos="100000">
+              <a:schemeClr val="phClr">
+                <a:shade val="63000"/>
+                <a:satMod val="120000"/>
+              </a:schemeClr>
+            </a:gs>
+          </a:gsLst>
+          <a:lin ang="5400000" scaled="0"/>
+        </a:gradFill>
+      </a:bgFillStyleLst>
+    </a:fmtScheme>
+  </a:themeElements>
+  <a:objectDefaults>
+    <a:lnDef>
+      <a:spPr/>
+      <a:bodyPr/>
+      <a:lstStyle/>
+      <a:style>
+        <a:lnRef idx="2">
+          <a:schemeClr val="accent1"/>
+        </a:lnRef>
+        <a:fillRef idx="0">
+          <a:schemeClr val="accent1"/>
+        </a:fillRef>
+        <a:effectRef idx="1">
+          <a:schemeClr val="accent1"/>
+        </a:effectRef>
+        <a:fontRef idx="minor">
+          <a:schemeClr val="tx1"/>
+        </a:fontRef>
+      </a:style>
+    </a:lnDef>
+  </a:objectDefaults>
+  <a:extraClrSchemeLst/>
+  <a:extLst>
+    <a:ext uri="{05A4C25C-085E-4340-85A3-A5531E510DB2}">
+      <thm15:themeFamily xmlns:thm15="http://schemas.microsoft.com/office/thememl/2012/main" name="Office Theme" id="{2E142A2C-CD16-42D6-873A-C26D2A0506FA}" vid="{1BDDFF52-6CD6-40A5-AB3C-68EB2F1E4D0A}"/>
+    </a:ext>
+  </a:extLst>
+</a:theme>
 </file>
</xml_diff>